<commit_message>
Actualizar materiales de clases 6 y 7
</commit_message>
<xml_diff>
--- a/clase_7/teoria/Clase_7.pptx
+++ b/clase_7/teoria/Clase_7.pptx
@@ -19,8 +19,8 @@
     <p:sldId id="266" r:id="rId10"/>
     <p:sldId id="289" r:id="rId11"/>
     <p:sldId id="290" r:id="rId12"/>
-    <p:sldId id="268" r:id="rId13"/>
-    <p:sldId id="285" r:id="rId14"/>
+    <p:sldId id="285" r:id="rId13"/>
+    <p:sldId id="268" r:id="rId14"/>
     <p:sldId id="284" r:id="rId15"/>
     <p:sldId id="286" r:id="rId16"/>
     <p:sldId id="287" r:id="rId17"/>
@@ -293,7 +293,7 @@
       </p15:sldGuideLst>
     </p:ext>
     <p:ext uri="GoogleSlidesCustomDataVersion2">
-      <go:slidesCustomData xmlns:go="http://customooxmlschemas.google.com/" xmlns:ahyp="http://schemas.microsoft.com/office/drawing/2018/hyperlinkcolor" xmlns:p15="http://schemas.microsoft.com/office/powerpoint/2012/main" xmlns:p14="http://schemas.microsoft.com/office/powerpoint/2010/main" xmlns:com="http://schemas.openxmlformats.org/drawingml/2006/compatibility" xmlns:pvml="urn:schemas-microsoft-com:office:powerpoint" xmlns:v="urn:schemas-microsoft-com:vml" xmlns:o="urn:schemas-microsoft-com:office:office" xmlns:dgm="http://schemas.openxmlformats.org/drawingml/2006/diagram" xmlns:c="http://schemas.openxmlformats.org/drawingml/2006/chart" xmlns:mv="urn:schemas-microsoft-com:mac:vml" xmlns:mc="http://schemas.openxmlformats.org/markup-compatibility/2006" xmlns="" r:id="rId41" roundtripDataSignature="AMtx7mjFLyGGbKtZ6MKWK8o6r1g77If8Vw=="/>
+      <go:slidesCustomData xmlns="" xmlns:mc="http://schemas.openxmlformats.org/markup-compatibility/2006" xmlns:mv="urn:schemas-microsoft-com:mac:vml" xmlns:c="http://schemas.openxmlformats.org/drawingml/2006/chart" xmlns:dgm="http://schemas.openxmlformats.org/drawingml/2006/diagram" xmlns:o="urn:schemas-microsoft-com:office:office" xmlns:v="urn:schemas-microsoft-com:vml" xmlns:pvml="urn:schemas-microsoft-com:office:powerpoint" xmlns:com="http://schemas.openxmlformats.org/drawingml/2006/compatibility" xmlns:p14="http://schemas.microsoft.com/office/powerpoint/2010/main" xmlns:p15="http://schemas.microsoft.com/office/powerpoint/2012/main" xmlns:ahyp="http://schemas.microsoft.com/office/drawing/2018/hyperlinkcolor" xmlns:go="http://customooxmlschemas.google.com/" r:id="rId41" roundtripDataSignature="AMtx7mjFLyGGbKtZ6MKWK8o6r1g77If8Vw=="/>
     </p:ext>
   </p:extLst>
 </p:presentation>
@@ -302,7 +302,7 @@
 <file path=ppt/revisionInfo.xml><?xml version="1.0" encoding="utf-8"?>
 <p1510:revInfo xmlns:a="http://schemas.openxmlformats.org/drawingml/2006/main" xmlns:r="http://schemas.openxmlformats.org/officeDocument/2006/relationships" xmlns:p1510="http://schemas.microsoft.com/office/powerpoint/2015/10/main">
   <p1510:revLst>
-    <p1510:client id="{46EBE5CE-8B26-408D-B50F-FC0A92A9D305}" v="9" dt="2026-10-05T21:55:41.016"/>
+    <p1510:client id="{46EBE5CE-8B26-408D-B50F-FC0A92A9D305}" v="17" dt="2026-10-06T19:59:36.201"/>
   </p1510:revLst>
 </p1510:revInfo>
 </file>
@@ -312,7 +312,7 @@
   <pc:docChgLst>
     <pc:chgData name="Marcos Maillot" userId="fa14b39d-e966-4ebb-a436-4f96f84b9577" providerId="ADAL" clId="{152A8D8E-FC9A-4326-9172-4A160D290924}"/>
     <pc:docChg chg="undo custSel addSld delSld modSld sldOrd">
-      <pc:chgData name="Marcos Maillot" userId="fa14b39d-e966-4ebb-a436-4f96f84b9577" providerId="ADAL" clId="{152A8D8E-FC9A-4326-9172-4A160D290924}" dt="2026-10-05T22:50:12.693" v="1215" actId="20577"/>
+      <pc:chgData name="Marcos Maillot" userId="fa14b39d-e966-4ebb-a436-4f96f84b9577" providerId="ADAL" clId="{152A8D8E-FC9A-4326-9172-4A160D290924}" dt="2026-10-06T20:27:09.352" v="1334" actId="1076"/>
       <pc:docMkLst>
         <pc:docMk/>
       </pc:docMkLst>
@@ -407,7 +407,7 @@
         </pc:sldMkLst>
       </pc:sldChg>
       <pc:sldChg chg="ord modNotes">
-        <pc:chgData name="Marcos Maillot" userId="fa14b39d-e966-4ebb-a436-4f96f84b9577" providerId="ADAL" clId="{152A8D8E-FC9A-4326-9172-4A160D290924}" dt="2026-10-05T21:35:06.090" v="1112"/>
+        <pc:chgData name="Marcos Maillot" userId="fa14b39d-e966-4ebb-a436-4f96f84b9577" providerId="ADAL" clId="{152A8D8E-FC9A-4326-9172-4A160D290924}" dt="2026-10-06T20:27:04.010" v="1332"/>
         <pc:sldMkLst>
           <pc:docMk/>
           <pc:sldMk cId="0" sldId="268"/>
@@ -549,6 +549,235 @@
           </ac:spMkLst>
         </pc:spChg>
       </pc:sldChg>
+      <pc:sldChg chg="addSp modSp mod modAnim">
+        <pc:chgData name="Marcos Maillot" userId="fa14b39d-e966-4ebb-a436-4f96f84b9577" providerId="ADAL" clId="{152A8D8E-FC9A-4326-9172-4A160D290924}" dt="2026-10-06T19:59:36.201" v="1239"/>
+        <pc:sldMkLst>
+          <pc:docMk/>
+          <pc:sldMk cId="3698410795" sldId="281"/>
+        </pc:sldMkLst>
+        <pc:spChg chg="add mod">
+          <ac:chgData name="Marcos Maillot" userId="fa14b39d-e966-4ebb-a436-4f96f84b9577" providerId="ADAL" clId="{152A8D8E-FC9A-4326-9172-4A160D290924}" dt="2026-10-06T19:58:48.117" v="1231" actId="1076"/>
+          <ac:spMkLst>
+            <pc:docMk/>
+            <pc:sldMk cId="3698410795" sldId="281"/>
+            <ac:spMk id="3" creationId="{BAD49A31-48C8-3780-594C-E0125770125F}"/>
+          </ac:spMkLst>
+        </pc:spChg>
+        <pc:spChg chg="mod">
+          <ac:chgData name="Marcos Maillot" userId="fa14b39d-e966-4ebb-a436-4f96f84b9577" providerId="ADAL" clId="{152A8D8E-FC9A-4326-9172-4A160D290924}" dt="2026-10-06T19:58:27.797" v="1218" actId="6549"/>
+          <ac:spMkLst>
+            <pc:docMk/>
+            <pc:sldMk cId="3698410795" sldId="281"/>
+            <ac:spMk id="202" creationId="{B03FFB50-A0E3-911B-80C4-8D35D952D00D}"/>
+          </ac:spMkLst>
+        </pc:spChg>
+      </pc:sldChg>
+      <pc:sldChg chg="addSp delSp modSp mod">
+        <pc:chgData name="Marcos Maillot" userId="fa14b39d-e966-4ebb-a436-4f96f84b9577" providerId="ADAL" clId="{152A8D8E-FC9A-4326-9172-4A160D290924}" dt="2026-10-06T20:27:09.352" v="1334" actId="1076"/>
+        <pc:sldMkLst>
+          <pc:docMk/>
+          <pc:sldMk cId="3636683501" sldId="284"/>
+        </pc:sldMkLst>
+        <pc:spChg chg="del">
+          <ac:chgData name="Marcos Maillot" userId="fa14b39d-e966-4ebb-a436-4f96f84b9577" providerId="ADAL" clId="{152A8D8E-FC9A-4326-9172-4A160D290924}" dt="2026-10-06T20:16:16.840" v="1317" actId="478"/>
+          <ac:spMkLst>
+            <pc:docMk/>
+            <pc:sldMk cId="3636683501" sldId="284"/>
+            <ac:spMk id="4" creationId="{5B839E1E-554B-65AC-A7C3-85FFDAB7A83F}"/>
+          </ac:spMkLst>
+        </pc:spChg>
+        <pc:spChg chg="del">
+          <ac:chgData name="Marcos Maillot" userId="fa14b39d-e966-4ebb-a436-4f96f84b9577" providerId="ADAL" clId="{152A8D8E-FC9A-4326-9172-4A160D290924}" dt="2026-10-06T20:16:13.447" v="1316" actId="478"/>
+          <ac:spMkLst>
+            <pc:docMk/>
+            <pc:sldMk cId="3636683501" sldId="284"/>
+            <ac:spMk id="7" creationId="{BEE56B23-341F-DBD7-E8DA-372DDE715C9E}"/>
+          </ac:spMkLst>
+        </pc:spChg>
+        <pc:spChg chg="del">
+          <ac:chgData name="Marcos Maillot" userId="fa14b39d-e966-4ebb-a436-4f96f84b9577" providerId="ADAL" clId="{152A8D8E-FC9A-4326-9172-4A160D290924}" dt="2026-10-06T20:16:13.447" v="1316" actId="478"/>
+          <ac:spMkLst>
+            <pc:docMk/>
+            <pc:sldMk cId="3636683501" sldId="284"/>
+            <ac:spMk id="10" creationId="{5C64B54E-77D2-53F4-ED48-4839DF7770D9}"/>
+          </ac:spMkLst>
+        </pc:spChg>
+        <pc:spChg chg="del">
+          <ac:chgData name="Marcos Maillot" userId="fa14b39d-e966-4ebb-a436-4f96f84b9577" providerId="ADAL" clId="{152A8D8E-FC9A-4326-9172-4A160D290924}" dt="2026-10-06T20:16:13.447" v="1316" actId="478"/>
+          <ac:spMkLst>
+            <pc:docMk/>
+            <pc:sldMk cId="3636683501" sldId="284"/>
+            <ac:spMk id="11" creationId="{245BCB9B-BC5E-A8D9-B15C-291C94FEC326}"/>
+          </ac:spMkLst>
+        </pc:spChg>
+        <pc:spChg chg="del">
+          <ac:chgData name="Marcos Maillot" userId="fa14b39d-e966-4ebb-a436-4f96f84b9577" providerId="ADAL" clId="{152A8D8E-FC9A-4326-9172-4A160D290924}" dt="2026-10-06T20:16:13.447" v="1316" actId="478"/>
+          <ac:spMkLst>
+            <pc:docMk/>
+            <pc:sldMk cId="3636683501" sldId="284"/>
+            <ac:spMk id="12" creationId="{B9315433-840C-5FED-1729-50367699B95C}"/>
+          </ac:spMkLst>
+        </pc:spChg>
+        <pc:spChg chg="del">
+          <ac:chgData name="Marcos Maillot" userId="fa14b39d-e966-4ebb-a436-4f96f84b9577" providerId="ADAL" clId="{152A8D8E-FC9A-4326-9172-4A160D290924}" dt="2026-10-06T20:16:13.447" v="1316" actId="478"/>
+          <ac:spMkLst>
+            <pc:docMk/>
+            <pc:sldMk cId="3636683501" sldId="284"/>
+            <ac:spMk id="13" creationId="{3AECCDD5-CA7D-1C2A-6F6E-498E4B0AFE57}"/>
+          </ac:spMkLst>
+        </pc:spChg>
+        <pc:picChg chg="del">
+          <ac:chgData name="Marcos Maillot" userId="fa14b39d-e966-4ebb-a436-4f96f84b9577" providerId="ADAL" clId="{152A8D8E-FC9A-4326-9172-4A160D290924}" dt="2026-10-06T20:16:13.447" v="1316" actId="478"/>
+          <ac:picMkLst>
+            <pc:docMk/>
+            <pc:sldMk cId="3636683501" sldId="284"/>
+            <ac:picMk id="3" creationId="{4BB7FF96-0A4A-881B-92F2-2CDAE022ADEB}"/>
+          </ac:picMkLst>
+        </pc:picChg>
+        <pc:picChg chg="add del mod">
+          <ac:chgData name="Marcos Maillot" userId="fa14b39d-e966-4ebb-a436-4f96f84b9577" providerId="ADAL" clId="{152A8D8E-FC9A-4326-9172-4A160D290924}" dt="2026-10-06T20:08:00.947" v="1252" actId="478"/>
+          <ac:picMkLst>
+            <pc:docMk/>
+            <pc:sldMk cId="3636683501" sldId="284"/>
+            <ac:picMk id="5" creationId="{6AF3FFC1-F9C9-2A84-FA62-C37C44D82002}"/>
+          </ac:picMkLst>
+        </pc:picChg>
+        <pc:picChg chg="del">
+          <ac:chgData name="Marcos Maillot" userId="fa14b39d-e966-4ebb-a436-4f96f84b9577" providerId="ADAL" clId="{152A8D8E-FC9A-4326-9172-4A160D290924}" dt="2026-10-06T20:16:13.447" v="1316" actId="478"/>
+          <ac:picMkLst>
+            <pc:docMk/>
+            <pc:sldMk cId="3636683501" sldId="284"/>
+            <ac:picMk id="6" creationId="{736236D8-E150-6244-93D2-BC1EEA48D45F}"/>
+          </ac:picMkLst>
+        </pc:picChg>
+        <pc:picChg chg="del">
+          <ac:chgData name="Marcos Maillot" userId="fa14b39d-e966-4ebb-a436-4f96f84b9577" providerId="ADAL" clId="{152A8D8E-FC9A-4326-9172-4A160D290924}" dt="2026-10-06T20:16:13.447" v="1316" actId="478"/>
+          <ac:picMkLst>
+            <pc:docMk/>
+            <pc:sldMk cId="3636683501" sldId="284"/>
+            <ac:picMk id="9" creationId="{01DD52B7-6D92-C044-AFBB-50DB34546169}"/>
+          </ac:picMkLst>
+        </pc:picChg>
+        <pc:picChg chg="add del">
+          <ac:chgData name="Marcos Maillot" userId="fa14b39d-e966-4ebb-a436-4f96f84b9577" providerId="ADAL" clId="{152A8D8E-FC9A-4326-9172-4A160D290924}" dt="2026-10-06T20:04:29.386" v="1247" actId="478"/>
+          <ac:picMkLst>
+            <pc:docMk/>
+            <pc:sldMk cId="3636683501" sldId="284"/>
+            <ac:picMk id="14" creationId="{D50E67D0-BF02-45EA-3745-858A5A6EF29A}"/>
+          </ac:picMkLst>
+        </pc:picChg>
+        <pc:picChg chg="add mod modCrop">
+          <ac:chgData name="Marcos Maillot" userId="fa14b39d-e966-4ebb-a436-4f96f84b9577" providerId="ADAL" clId="{152A8D8E-FC9A-4326-9172-4A160D290924}" dt="2026-10-06T20:27:09.352" v="1334" actId="1076"/>
+          <ac:picMkLst>
+            <pc:docMk/>
+            <pc:sldMk cId="3636683501" sldId="284"/>
+            <ac:picMk id="16" creationId="{CE758913-E37A-D21E-A1F3-22919763CBC8}"/>
+          </ac:picMkLst>
+        </pc:picChg>
+        <pc:picChg chg="add mod modCrop">
+          <ac:chgData name="Marcos Maillot" userId="fa14b39d-e966-4ebb-a436-4f96f84b9577" providerId="ADAL" clId="{152A8D8E-FC9A-4326-9172-4A160D290924}" dt="2026-10-06T20:27:07.919" v="1333" actId="1076"/>
+          <ac:picMkLst>
+            <pc:docMk/>
+            <pc:sldMk cId="3636683501" sldId="284"/>
+            <ac:picMk id="18" creationId="{DE38000C-5826-28B7-2BCD-890B49B506FE}"/>
+          </ac:picMkLst>
+        </pc:picChg>
+      </pc:sldChg>
+      <pc:sldChg chg="addSp delSp modSp mod">
+        <pc:chgData name="Marcos Maillot" userId="fa14b39d-e966-4ebb-a436-4f96f84b9577" providerId="ADAL" clId="{152A8D8E-FC9A-4326-9172-4A160D290924}" dt="2026-10-06T20:14:25.148" v="1314" actId="20577"/>
+        <pc:sldMkLst>
+          <pc:docMk/>
+          <pc:sldMk cId="3925028538" sldId="286"/>
+        </pc:sldMkLst>
+        <pc:spChg chg="del mod">
+          <ac:chgData name="Marcos Maillot" userId="fa14b39d-e966-4ebb-a436-4f96f84b9577" providerId="ADAL" clId="{152A8D8E-FC9A-4326-9172-4A160D290924}" dt="2026-10-06T20:12:06.438" v="1268" actId="478"/>
+          <ac:spMkLst>
+            <pc:docMk/>
+            <pc:sldMk cId="3925028538" sldId="286"/>
+            <ac:spMk id="4" creationId="{C0AD1CD5-313C-8345-35E1-EE490B62DE69}"/>
+          </ac:spMkLst>
+        </pc:spChg>
+        <pc:spChg chg="del">
+          <ac:chgData name="Marcos Maillot" userId="fa14b39d-e966-4ebb-a436-4f96f84b9577" providerId="ADAL" clId="{152A8D8E-FC9A-4326-9172-4A160D290924}" dt="2026-10-06T20:12:03.623" v="1265" actId="478"/>
+          <ac:spMkLst>
+            <pc:docMk/>
+            <pc:sldMk cId="3925028538" sldId="286"/>
+            <ac:spMk id="7" creationId="{157AADA2-0864-34B0-682A-FC33B129A56A}"/>
+          </ac:spMkLst>
+        </pc:spChg>
+        <pc:spChg chg="add mod">
+          <ac:chgData name="Marcos Maillot" userId="fa14b39d-e966-4ebb-a436-4f96f84b9577" providerId="ADAL" clId="{152A8D8E-FC9A-4326-9172-4A160D290924}" dt="2026-10-06T20:14:25.148" v="1314" actId="20577"/>
+          <ac:spMkLst>
+            <pc:docMk/>
+            <pc:sldMk cId="3925028538" sldId="286"/>
+            <ac:spMk id="8" creationId="{871E2BA6-D16B-11DE-0106-60D3A846CFF5}"/>
+          </ac:spMkLst>
+        </pc:spChg>
+        <pc:spChg chg="del mod">
+          <ac:chgData name="Marcos Maillot" userId="fa14b39d-e966-4ebb-a436-4f96f84b9577" providerId="ADAL" clId="{152A8D8E-FC9A-4326-9172-4A160D290924}" dt="2026-10-06T20:12:05.153" v="1266" actId="478"/>
+          <ac:spMkLst>
+            <pc:docMk/>
+            <pc:sldMk cId="3925028538" sldId="286"/>
+            <ac:spMk id="10" creationId="{38743EAC-28CD-9FA0-BECC-C083B56EC437}"/>
+          </ac:spMkLst>
+        </pc:spChg>
+        <pc:spChg chg="mod">
+          <ac:chgData name="Marcos Maillot" userId="fa14b39d-e966-4ebb-a436-4f96f84b9577" providerId="ADAL" clId="{152A8D8E-FC9A-4326-9172-4A160D290924}" dt="2026-10-06T20:13:49.387" v="1286" actId="14100"/>
+          <ac:spMkLst>
+            <pc:docMk/>
+            <pc:sldMk cId="3925028538" sldId="286"/>
+            <ac:spMk id="11" creationId="{720055BD-D7D0-FC30-865A-55AA61DE09DC}"/>
+          </ac:spMkLst>
+        </pc:spChg>
+        <pc:spChg chg="mod">
+          <ac:chgData name="Marcos Maillot" userId="fa14b39d-e966-4ebb-a436-4f96f84b9577" providerId="ADAL" clId="{152A8D8E-FC9A-4326-9172-4A160D290924}" dt="2026-10-06T20:14:07.701" v="1302" actId="14100"/>
+          <ac:spMkLst>
+            <pc:docMk/>
+            <pc:sldMk cId="3925028538" sldId="286"/>
+            <ac:spMk id="12" creationId="{E6D49E6B-AA33-2ECE-16AF-4FEA9DD67BB2}"/>
+          </ac:spMkLst>
+        </pc:spChg>
+        <pc:spChg chg="mod">
+          <ac:chgData name="Marcos Maillot" userId="fa14b39d-e966-4ebb-a436-4f96f84b9577" providerId="ADAL" clId="{152A8D8E-FC9A-4326-9172-4A160D290924}" dt="2026-10-06T20:13:59.027" v="1294" actId="14100"/>
+          <ac:spMkLst>
+            <pc:docMk/>
+            <pc:sldMk cId="3925028538" sldId="286"/>
+            <ac:spMk id="13" creationId="{44954AE5-4D2C-BC9E-5B16-45CEAD3F25CD}"/>
+          </ac:spMkLst>
+        </pc:spChg>
+        <pc:picChg chg="add mod">
+          <ac:chgData name="Marcos Maillot" userId="fa14b39d-e966-4ebb-a436-4f96f84b9577" providerId="ADAL" clId="{152A8D8E-FC9A-4326-9172-4A160D290924}" dt="2026-10-06T20:12:17.812" v="1275" actId="1076"/>
+          <ac:picMkLst>
+            <pc:docMk/>
+            <pc:sldMk cId="3925028538" sldId="286"/>
+            <ac:picMk id="3" creationId="{8E821BB5-4B0C-F9FC-6B0E-F2C5762ADCC2}"/>
+          </ac:picMkLst>
+        </pc:picChg>
+        <pc:picChg chg="del">
+          <ac:chgData name="Marcos Maillot" userId="fa14b39d-e966-4ebb-a436-4f96f84b9577" providerId="ADAL" clId="{152A8D8E-FC9A-4326-9172-4A160D290924}" dt="2026-10-06T20:11:48.987" v="1255" actId="478"/>
+          <ac:picMkLst>
+            <pc:docMk/>
+            <pc:sldMk cId="3925028538" sldId="286"/>
+            <ac:picMk id="5" creationId="{6D46FC77-5229-22CA-AB3E-65B9588CE8DB}"/>
+          </ac:picMkLst>
+        </pc:picChg>
+        <pc:picChg chg="del">
+          <ac:chgData name="Marcos Maillot" userId="fa14b39d-e966-4ebb-a436-4f96f84b9577" providerId="ADAL" clId="{152A8D8E-FC9A-4326-9172-4A160D290924}" dt="2026-10-06T20:11:49.455" v="1256" actId="478"/>
+          <ac:picMkLst>
+            <pc:docMk/>
+            <pc:sldMk cId="3925028538" sldId="286"/>
+            <ac:picMk id="14" creationId="{E15E41EE-6008-E7F4-8976-B6C2188F6885}"/>
+          </ac:picMkLst>
+        </pc:picChg>
+        <pc:picChg chg="del">
+          <ac:chgData name="Marcos Maillot" userId="fa14b39d-e966-4ebb-a436-4f96f84b9577" providerId="ADAL" clId="{152A8D8E-FC9A-4326-9172-4A160D290924}" dt="2026-10-06T20:11:49.846" v="1257" actId="478"/>
+          <ac:picMkLst>
+            <pc:docMk/>
+            <pc:sldMk cId="3925028538" sldId="286"/>
+            <ac:picMk id="16" creationId="{00191610-9F0D-9904-AF50-B51EF8BB15EC}"/>
+          </ac:picMkLst>
+        </pc:picChg>
+      </pc:sldChg>
       <pc:sldChg chg="mod modShow">
         <pc:chgData name="Marcos Maillot" userId="fa14b39d-e966-4ebb-a436-4f96f84b9577" providerId="ADAL" clId="{152A8D8E-FC9A-4326-9172-4A160D290924}" dt="2026-10-05T21:23:32.056" v="1080" actId="729"/>
         <pc:sldMkLst>
@@ -618,6 +847,21 @@
             <ac:picMk id="174" creationId="{B416FA87-6251-7B71-988E-0AB2104FD86B}"/>
           </ac:picMkLst>
         </pc:picChg>
+      </pc:sldChg>
+      <pc:sldChg chg="modSp mod">
+        <pc:chgData name="Marcos Maillot" userId="fa14b39d-e966-4ebb-a436-4f96f84b9577" providerId="ADAL" clId="{152A8D8E-FC9A-4326-9172-4A160D290924}" dt="2026-10-06T20:15:45.094" v="1315" actId="20577"/>
+        <pc:sldMkLst>
+          <pc:docMk/>
+          <pc:sldMk cId="3510668493" sldId="290"/>
+        </pc:sldMkLst>
+        <pc:spChg chg="mod">
+          <ac:chgData name="Marcos Maillot" userId="fa14b39d-e966-4ebb-a436-4f96f84b9577" providerId="ADAL" clId="{152A8D8E-FC9A-4326-9172-4A160D290924}" dt="2026-10-06T20:15:45.094" v="1315" actId="20577"/>
+          <ac:spMkLst>
+            <pc:docMk/>
+            <pc:sldMk cId="3510668493" sldId="290"/>
+            <ac:spMk id="5" creationId="{67AAABE4-A20B-3D8B-40F4-10C92428844C}"/>
+          </ac:spMkLst>
+        </pc:spChg>
       </pc:sldChg>
     </pc:docChg>
   </pc:docChgLst>
@@ -1702,110 +1946,6 @@
   <p:cSld>
     <p:spTree>
       <p:nvGrpSpPr>
-        <p:cNvPr id="1" name="Shape 184"/>
-        <p:cNvGrpSpPr/>
-        <p:nvPr/>
-      </p:nvGrpSpPr>
-      <p:grpSpPr>
-        <a:xfrm>
-          <a:off x="0" y="0"/>
-          <a:ext cx="0" cy="0"/>
-          <a:chOff x="0" y="0"/>
-          <a:chExt cx="0" cy="0"/>
-        </a:xfrm>
-      </p:grpSpPr>
-      <p:sp>
-        <p:nvSpPr>
-          <p:cNvPr id="185" name="Google Shape;185;g2f19d644e1e_1_90:notes"/>
-          <p:cNvSpPr txBox="1">
-            <a:spLocks noGrp="1"/>
-          </p:cNvSpPr>
-          <p:nvPr>
-            <p:ph type="body" idx="1"/>
-          </p:nvPr>
-        </p:nvSpPr>
-        <p:spPr>
-          <a:xfrm>
-            <a:off x="685800" y="4343400"/>
-            <a:ext cx="5486400" cy="4114800"/>
-          </a:xfrm>
-          <a:prstGeom prst="rect">
-            <a:avLst/>
-          </a:prstGeom>
-        </p:spPr>
-        <p:txBody>
-          <a:bodyPr spcFirstLastPara="1" wrap="square" lIns="91425" tIns="91425" rIns="91425" bIns="91425" anchor="t" anchorCtr="0">
-            <a:noAutofit/>
-          </a:bodyPr>
-          <a:lstStyle/>
-          <a:p>
-            <a:pPr marL="0" lvl="0" indent="0" algn="l" rtl="0">
-              <a:spcBef>
-                <a:spcPts val="0"/>
-              </a:spcBef>
-              <a:spcAft>
-                <a:spcPts val="0"/>
-              </a:spcAft>
-              <a:buNone/>
-            </a:pPr>
-            <a:endParaRPr/>
-          </a:p>
-        </p:txBody>
-      </p:sp>
-      <p:sp>
-        <p:nvSpPr>
-          <p:cNvPr id="186" name="Google Shape;186;g2f19d644e1e_1_90:notes"/>
-          <p:cNvSpPr>
-            <a:spLocks noGrp="1" noRot="1" noChangeAspect="1"/>
-          </p:cNvSpPr>
-          <p:nvPr>
-            <p:ph type="sldImg" idx="2"/>
-          </p:nvPr>
-        </p:nvSpPr>
-        <p:spPr>
-          <a:xfrm>
-            <a:off x="381000" y="685800"/>
-            <a:ext cx="6096000" cy="3429000"/>
-          </a:xfrm>
-          <a:custGeom>
-            <a:avLst/>
-            <a:gdLst/>
-            <a:ahLst/>
-            <a:cxnLst/>
-            <a:rect l="l" t="t" r="r" b="b"/>
-            <a:pathLst>
-              <a:path w="120000" h="120000" extrusionOk="0">
-                <a:moveTo>
-                  <a:pt x="0" y="0"/>
-                </a:moveTo>
-                <a:lnTo>
-                  <a:pt x="120000" y="0"/>
-                </a:lnTo>
-                <a:lnTo>
-                  <a:pt x="120000" y="120000"/>
-                </a:lnTo>
-                <a:lnTo>
-                  <a:pt x="0" y="120000"/>
-                </a:lnTo>
-                <a:close/>
-              </a:path>
-            </a:pathLst>
-          </a:custGeom>
-        </p:spPr>
-      </p:sp>
-    </p:spTree>
-  </p:cSld>
-  <p:clrMapOvr>
-    <a:masterClrMapping/>
-  </p:clrMapOvr>
-</p:notes>
-</file>
-
-<file path=ppt/notesSlides/notesSlide13.xml><?xml version="1.0" encoding="utf-8"?>
-<p:notes xmlns:a="http://schemas.openxmlformats.org/drawingml/2006/main" xmlns:r="http://schemas.openxmlformats.org/officeDocument/2006/relationships" xmlns:p="http://schemas.openxmlformats.org/presentationml/2006/main" showMasterSp="0" showMasterPhAnim="0">
-  <p:cSld>
-    <p:spTree>
-      <p:nvGrpSpPr>
         <p:cNvPr id="1" name="Shape 184">
           <a:extLst>
             <a:ext uri="{FF2B5EF4-FFF2-40B4-BE49-F238E27FC236}">
@@ -1921,6 +2061,110 @@
         <p14:creationId xmlns:p14="http://schemas.microsoft.com/office/powerpoint/2010/main" val="1054386876"/>
       </p:ext>
     </p:extLst>
+  </p:cSld>
+  <p:clrMapOvr>
+    <a:masterClrMapping/>
+  </p:clrMapOvr>
+</p:notes>
+</file>
+
+<file path=ppt/notesSlides/notesSlide13.xml><?xml version="1.0" encoding="utf-8"?>
+<p:notes xmlns:a="http://schemas.openxmlformats.org/drawingml/2006/main" xmlns:r="http://schemas.openxmlformats.org/officeDocument/2006/relationships" xmlns:p="http://schemas.openxmlformats.org/presentationml/2006/main" showMasterSp="0" showMasterPhAnim="0">
+  <p:cSld>
+    <p:spTree>
+      <p:nvGrpSpPr>
+        <p:cNvPr id="1" name="Shape 184"/>
+        <p:cNvGrpSpPr/>
+        <p:nvPr/>
+      </p:nvGrpSpPr>
+      <p:grpSpPr>
+        <a:xfrm>
+          <a:off x="0" y="0"/>
+          <a:ext cx="0" cy="0"/>
+          <a:chOff x="0" y="0"/>
+          <a:chExt cx="0" cy="0"/>
+        </a:xfrm>
+      </p:grpSpPr>
+      <p:sp>
+        <p:nvSpPr>
+          <p:cNvPr id="185" name="Google Shape;185;g2f19d644e1e_1_90:notes"/>
+          <p:cNvSpPr txBox="1">
+            <a:spLocks noGrp="1"/>
+          </p:cNvSpPr>
+          <p:nvPr>
+            <p:ph type="body" idx="1"/>
+          </p:nvPr>
+        </p:nvSpPr>
+        <p:spPr>
+          <a:xfrm>
+            <a:off x="685800" y="4343400"/>
+            <a:ext cx="5486400" cy="4114800"/>
+          </a:xfrm>
+          <a:prstGeom prst="rect">
+            <a:avLst/>
+          </a:prstGeom>
+        </p:spPr>
+        <p:txBody>
+          <a:bodyPr spcFirstLastPara="1" wrap="square" lIns="91425" tIns="91425" rIns="91425" bIns="91425" anchor="t" anchorCtr="0">
+            <a:noAutofit/>
+          </a:bodyPr>
+          <a:lstStyle/>
+          <a:p>
+            <a:pPr marL="0" lvl="0" indent="0" algn="l" rtl="0">
+              <a:spcBef>
+                <a:spcPts val="0"/>
+              </a:spcBef>
+              <a:spcAft>
+                <a:spcPts val="0"/>
+              </a:spcAft>
+              <a:buNone/>
+            </a:pPr>
+            <a:endParaRPr/>
+          </a:p>
+        </p:txBody>
+      </p:sp>
+      <p:sp>
+        <p:nvSpPr>
+          <p:cNvPr id="186" name="Google Shape;186;g2f19d644e1e_1_90:notes"/>
+          <p:cNvSpPr>
+            <a:spLocks noGrp="1" noRot="1" noChangeAspect="1"/>
+          </p:cNvSpPr>
+          <p:nvPr>
+            <p:ph type="sldImg" idx="2"/>
+          </p:nvPr>
+        </p:nvSpPr>
+        <p:spPr>
+          <a:xfrm>
+            <a:off x="381000" y="685800"/>
+            <a:ext cx="6096000" cy="3429000"/>
+          </a:xfrm>
+          <a:custGeom>
+            <a:avLst/>
+            <a:gdLst/>
+            <a:ahLst/>
+            <a:cxnLst/>
+            <a:rect l="l" t="t" r="r" b="b"/>
+            <a:pathLst>
+              <a:path w="120000" h="120000" extrusionOk="0">
+                <a:moveTo>
+                  <a:pt x="0" y="0"/>
+                </a:moveTo>
+                <a:lnTo>
+                  <a:pt x="120000" y="0"/>
+                </a:lnTo>
+                <a:lnTo>
+                  <a:pt x="120000" y="120000"/>
+                </a:lnTo>
+                <a:lnTo>
+                  <a:pt x="0" y="120000"/>
+                </a:lnTo>
+                <a:close/>
+              </a:path>
+            </a:pathLst>
+          </a:custGeom>
+        </p:spPr>
+      </p:sp>
+    </p:spTree>
   </p:cSld>
   <p:clrMapOvr>
     <a:masterClrMapping/>
@@ -4828,7 +5072,7 @@
             </a:pPr>
             <a:fld id="{00000000-1234-1234-1234-123412341234}" type="slidenum">
               <a:rPr lang="en"/>
-              <a:t>‹Nº›</a:t>
+              <a:t>‹#›</a:t>
             </a:fld>
             <a:endParaRPr/>
           </a:p>
@@ -5527,7 +5771,7 @@
             </a:pPr>
             <a:fld id="{00000000-1234-1234-1234-123412341234}" type="slidenum">
               <a:rPr lang="en"/>
-              <a:t>‹Nº›</a:t>
+              <a:t>‹#›</a:t>
             </a:fld>
             <a:endParaRPr/>
           </a:p>
@@ -5841,7 +6085,7 @@
             </a:pPr>
             <a:fld id="{00000000-1234-1234-1234-123412341234}" type="slidenum">
               <a:rPr lang="en"/>
-              <a:t>‹Nº›</a:t>
+              <a:t>‹#›</a:t>
             </a:fld>
             <a:endParaRPr/>
           </a:p>
@@ -7033,7 +7277,7 @@
             </a:pPr>
             <a:fld id="{00000000-1234-1234-1234-123412341234}" type="slidenum">
               <a:rPr lang="en"/>
-              <a:t>‹Nº›</a:t>
+              <a:t>‹#›</a:t>
             </a:fld>
             <a:endParaRPr/>
           </a:p>
@@ -7785,7 +8029,7 @@
             </a:pPr>
             <a:fld id="{00000000-1234-1234-1234-123412341234}" type="slidenum">
               <a:rPr lang="en"/>
-              <a:t>‹Nº›</a:t>
+              <a:t>‹#›</a:t>
             </a:fld>
             <a:endParaRPr/>
           </a:p>
@@ -8377,7 +8621,7 @@
             </a:pPr>
             <a:fld id="{00000000-1234-1234-1234-123412341234}" type="slidenum">
               <a:rPr lang="en"/>
-              <a:t>‹Nº›</a:t>
+              <a:t>‹#›</a:t>
             </a:fld>
             <a:endParaRPr/>
           </a:p>
@@ -8843,7 +9087,7 @@
             </a:pPr>
             <a:fld id="{00000000-1234-1234-1234-123412341234}" type="slidenum">
               <a:rPr lang="en"/>
-              <a:t>‹Nº›</a:t>
+              <a:t>‹#›</a:t>
             </a:fld>
             <a:endParaRPr/>
           </a:p>
@@ -9755,7 +9999,7 @@
             </a:pPr>
             <a:fld id="{00000000-1234-1234-1234-123412341234}" type="slidenum">
               <a:rPr lang="en"/>
-              <a:t>‹Nº›</a:t>
+              <a:t>‹#›</a:t>
             </a:fld>
             <a:endParaRPr/>
           </a:p>
@@ -10570,7 +10814,7 @@
             </a:pPr>
             <a:fld id="{00000000-1234-1234-1234-123412341234}" type="slidenum">
               <a:rPr lang="en"/>
-              <a:t>‹Nº›</a:t>
+              <a:t>‹#›</a:t>
             </a:fld>
             <a:endParaRPr/>
           </a:p>
@@ -11036,7 +11280,7 @@
             </a:pPr>
             <a:fld id="{00000000-1234-1234-1234-123412341234}" type="slidenum">
               <a:rPr lang="en"/>
-              <a:t>‹Nº›</a:t>
+              <a:t>‹#›</a:t>
             </a:fld>
             <a:endParaRPr/>
           </a:p>
@@ -12074,7 +12318,7 @@
             </a:pPr>
             <a:fld id="{00000000-1234-1234-1234-123412341234}" type="slidenum">
               <a:rPr lang="en"/>
-              <a:t>‹Nº›</a:t>
+              <a:t>‹#›</a:t>
             </a:fld>
             <a:endParaRPr/>
           </a:p>
@@ -12561,7 +12805,7 @@
             </a:pPr>
             <a:fld id="{00000000-1234-1234-1234-123412341234}" type="slidenum">
               <a:rPr lang="en"/>
-              <a:t>‹Nº›</a:t>
+              <a:t>‹#›</a:t>
             </a:fld>
             <a:endParaRPr/>
           </a:p>
@@ -13411,7 +13655,7 @@
             </a:pPr>
             <a:fld id="{00000000-1234-1234-1234-123412341234}" type="slidenum">
               <a:rPr lang="en"/>
-              <a:t>‹Nº›</a:t>
+              <a:t>‹#›</a:t>
             </a:fld>
             <a:endParaRPr/>
           </a:p>
@@ -14879,7 +15123,7 @@
           <a:p>
             <a:r>
               <a:rPr lang="es-ES" dirty="0"/>
-              <a:t>Los beta-VAE busca hacer una representación </a:t>
+              <a:t>Los beta-VAE buscan hacer una representación </a:t>
             </a:r>
             <a:r>
               <a:rPr lang="es-ES" dirty="0" err="1"/>
@@ -15216,163 +15460,6 @@
 </file>
 
 <file path=ppt/slides/slide12.xml><?xml version="1.0" encoding="utf-8"?>
-<p:sld xmlns:a="http://schemas.openxmlformats.org/drawingml/2006/main" xmlns:r="http://schemas.openxmlformats.org/officeDocument/2006/relationships" xmlns:p="http://schemas.openxmlformats.org/presentationml/2006/main">
-  <p:cSld>
-    <p:spTree>
-      <p:nvGrpSpPr>
-        <p:cNvPr id="1" name="Shape 187"/>
-        <p:cNvGrpSpPr/>
-        <p:nvPr/>
-      </p:nvGrpSpPr>
-      <p:grpSpPr>
-        <a:xfrm>
-          <a:off x="0" y="0"/>
-          <a:ext cx="0" cy="0"/>
-          <a:chOff x="0" y="0"/>
-          <a:chExt cx="0" cy="0"/>
-        </a:xfrm>
-      </p:grpSpPr>
-      <p:sp>
-        <p:nvSpPr>
-          <p:cNvPr id="188" name="Google Shape;188;g2f19d644e1e_1_90"/>
-          <p:cNvSpPr txBox="1"/>
-          <p:nvPr/>
-        </p:nvSpPr>
-        <p:spPr>
-          <a:xfrm>
-            <a:off x="-129402" y="0"/>
-            <a:ext cx="9383400" cy="814500"/>
-          </a:xfrm>
-          <a:prstGeom prst="rect">
-            <a:avLst/>
-          </a:prstGeom>
-          <a:noFill/>
-          <a:ln>
-            <a:noFill/>
-          </a:ln>
-        </p:spPr>
-        <p:txBody>
-          <a:bodyPr spcFirstLastPara="1" wrap="square" lIns="68575" tIns="34275" rIns="68575" bIns="34275" anchor="t" anchorCtr="0">
-            <a:noAutofit/>
-          </a:bodyPr>
-          <a:lstStyle/>
-          <a:p>
-            <a:pPr marL="0" marR="0" lvl="0" indent="0" algn="ctr" rtl="0">
-              <a:lnSpc>
-                <a:spcPct val="120000"/>
-              </a:lnSpc>
-              <a:spcBef>
-                <a:spcPts val="0"/>
-              </a:spcBef>
-              <a:spcAft>
-                <a:spcPts val="0"/>
-              </a:spcAft>
-              <a:buClr>
-                <a:schemeClr val="dk1"/>
-              </a:buClr>
-              <a:buSzPts val="3000"/>
-              <a:buFont typeface="Arial"/>
-              <a:buNone/>
-            </a:pPr>
-            <a:r>
-              <a:rPr lang="en" sz="2400">
-                <a:solidFill>
-                  <a:schemeClr val="dk2"/>
-                </a:solidFill>
-                <a:latin typeface="Twentieth Century"/>
-                <a:ea typeface="Twentieth Century"/>
-                <a:cs typeface="Twentieth Century"/>
-                <a:sym typeface="Twentieth Century"/>
-              </a:rPr>
-              <a:t>Autoencoders</a:t>
-            </a:r>
-            <a:endParaRPr sz="2400">
-              <a:solidFill>
-                <a:schemeClr val="dk2"/>
-              </a:solidFill>
-              <a:latin typeface="Twentieth Century"/>
-              <a:ea typeface="Twentieth Century"/>
-              <a:cs typeface="Twentieth Century"/>
-              <a:sym typeface="Twentieth Century"/>
-            </a:endParaRPr>
-          </a:p>
-        </p:txBody>
-      </p:sp>
-      <p:sp>
-        <p:nvSpPr>
-          <p:cNvPr id="189" name="Google Shape;189;g2f19d644e1e_1_90"/>
-          <p:cNvSpPr txBox="1"/>
-          <p:nvPr/>
-        </p:nvSpPr>
-        <p:spPr>
-          <a:xfrm>
-            <a:off x="612588" y="2049328"/>
-            <a:ext cx="5327792" cy="317166"/>
-          </a:xfrm>
-          <a:prstGeom prst="rect">
-            <a:avLst/>
-          </a:prstGeom>
-          <a:noFill/>
-          <a:ln>
-            <a:noFill/>
-          </a:ln>
-        </p:spPr>
-        <p:txBody>
-          <a:bodyPr spcFirstLastPara="1" wrap="square" lIns="68575" tIns="34275" rIns="68575" bIns="34275" anchor="t" anchorCtr="0">
-            <a:noAutofit/>
-          </a:bodyPr>
-          <a:lstStyle/>
-          <a:p>
-            <a:pPr marL="0" marR="0" lvl="0" indent="0" algn="l" rtl="0">
-              <a:lnSpc>
-                <a:spcPct val="90000"/>
-              </a:lnSpc>
-              <a:spcBef>
-                <a:spcPts val="0"/>
-              </a:spcBef>
-              <a:spcAft>
-                <a:spcPts val="0"/>
-              </a:spcAft>
-              <a:buClr>
-                <a:srgbClr val="FF0000"/>
-              </a:buClr>
-              <a:buSzPts val="2100"/>
-              <a:buFont typeface="Arial"/>
-              <a:buNone/>
-            </a:pPr>
-            <a:r>
-              <a:rPr lang="en" sz="2100" dirty="0">
-                <a:solidFill>
-                  <a:srgbClr val="FF0000"/>
-                </a:solidFill>
-                <a:latin typeface="Twentieth Century"/>
-                <a:ea typeface="Twentieth Century"/>
-                <a:cs typeface="Twentieth Century"/>
-                <a:sym typeface="Twentieth Century"/>
-              </a:rPr>
-              <a:t> ver colab autoencoder</a:t>
-            </a:r>
-            <a:endParaRPr sz="2100" dirty="0">
-              <a:solidFill>
-                <a:srgbClr val="FF0000"/>
-              </a:solidFill>
-              <a:latin typeface="Twentieth Century"/>
-              <a:ea typeface="Twentieth Century"/>
-              <a:cs typeface="Twentieth Century"/>
-              <a:sym typeface="Twentieth Century"/>
-            </a:endParaRPr>
-          </a:p>
-        </p:txBody>
-      </p:sp>
-    </p:spTree>
-  </p:cSld>
-  <p:clrMapOvr>
-    <a:masterClrMapping/>
-  </p:clrMapOvr>
-</p:sld>
-</file>
-
-<file path=ppt/slides/slide13.xml><?xml version="1.0" encoding="utf-8"?>
 <p:sld xmlns:a="http://schemas.openxmlformats.org/drawingml/2006/main" xmlns:r="http://schemas.openxmlformats.org/officeDocument/2006/relationships" xmlns:p="http://schemas.openxmlformats.org/presentationml/2006/main">
   <p:cSld>
     <p:spTree>
@@ -15918,6 +16005,163 @@
 </p:sld>
 </file>
 
+<file path=ppt/slides/slide13.xml><?xml version="1.0" encoding="utf-8"?>
+<p:sld xmlns:a="http://schemas.openxmlformats.org/drawingml/2006/main" xmlns:r="http://schemas.openxmlformats.org/officeDocument/2006/relationships" xmlns:p="http://schemas.openxmlformats.org/presentationml/2006/main">
+  <p:cSld>
+    <p:spTree>
+      <p:nvGrpSpPr>
+        <p:cNvPr id="1" name="Shape 187"/>
+        <p:cNvGrpSpPr/>
+        <p:nvPr/>
+      </p:nvGrpSpPr>
+      <p:grpSpPr>
+        <a:xfrm>
+          <a:off x="0" y="0"/>
+          <a:ext cx="0" cy="0"/>
+          <a:chOff x="0" y="0"/>
+          <a:chExt cx="0" cy="0"/>
+        </a:xfrm>
+      </p:grpSpPr>
+      <p:sp>
+        <p:nvSpPr>
+          <p:cNvPr id="188" name="Google Shape;188;g2f19d644e1e_1_90"/>
+          <p:cNvSpPr txBox="1"/>
+          <p:nvPr/>
+        </p:nvSpPr>
+        <p:spPr>
+          <a:xfrm>
+            <a:off x="-129402" y="0"/>
+            <a:ext cx="9383400" cy="814500"/>
+          </a:xfrm>
+          <a:prstGeom prst="rect">
+            <a:avLst/>
+          </a:prstGeom>
+          <a:noFill/>
+          <a:ln>
+            <a:noFill/>
+          </a:ln>
+        </p:spPr>
+        <p:txBody>
+          <a:bodyPr spcFirstLastPara="1" wrap="square" lIns="68575" tIns="34275" rIns="68575" bIns="34275" anchor="t" anchorCtr="0">
+            <a:noAutofit/>
+          </a:bodyPr>
+          <a:lstStyle/>
+          <a:p>
+            <a:pPr marL="0" marR="0" lvl="0" indent="0" algn="ctr" rtl="0">
+              <a:lnSpc>
+                <a:spcPct val="120000"/>
+              </a:lnSpc>
+              <a:spcBef>
+                <a:spcPts val="0"/>
+              </a:spcBef>
+              <a:spcAft>
+                <a:spcPts val="0"/>
+              </a:spcAft>
+              <a:buClr>
+                <a:schemeClr val="dk1"/>
+              </a:buClr>
+              <a:buSzPts val="3000"/>
+              <a:buFont typeface="Arial"/>
+              <a:buNone/>
+            </a:pPr>
+            <a:r>
+              <a:rPr lang="en" sz="2400">
+                <a:solidFill>
+                  <a:schemeClr val="dk2"/>
+                </a:solidFill>
+                <a:latin typeface="Twentieth Century"/>
+                <a:ea typeface="Twentieth Century"/>
+                <a:cs typeface="Twentieth Century"/>
+                <a:sym typeface="Twentieth Century"/>
+              </a:rPr>
+              <a:t>Autoencoders</a:t>
+            </a:r>
+            <a:endParaRPr sz="2400">
+              <a:solidFill>
+                <a:schemeClr val="dk2"/>
+              </a:solidFill>
+              <a:latin typeface="Twentieth Century"/>
+              <a:ea typeface="Twentieth Century"/>
+              <a:cs typeface="Twentieth Century"/>
+              <a:sym typeface="Twentieth Century"/>
+            </a:endParaRPr>
+          </a:p>
+        </p:txBody>
+      </p:sp>
+      <p:sp>
+        <p:nvSpPr>
+          <p:cNvPr id="189" name="Google Shape;189;g2f19d644e1e_1_90"/>
+          <p:cNvSpPr txBox="1"/>
+          <p:nvPr/>
+        </p:nvSpPr>
+        <p:spPr>
+          <a:xfrm>
+            <a:off x="612588" y="2049328"/>
+            <a:ext cx="5327792" cy="317166"/>
+          </a:xfrm>
+          <a:prstGeom prst="rect">
+            <a:avLst/>
+          </a:prstGeom>
+          <a:noFill/>
+          <a:ln>
+            <a:noFill/>
+          </a:ln>
+        </p:spPr>
+        <p:txBody>
+          <a:bodyPr spcFirstLastPara="1" wrap="square" lIns="68575" tIns="34275" rIns="68575" bIns="34275" anchor="t" anchorCtr="0">
+            <a:noAutofit/>
+          </a:bodyPr>
+          <a:lstStyle/>
+          <a:p>
+            <a:pPr marL="0" marR="0" lvl="0" indent="0" algn="l" rtl="0">
+              <a:lnSpc>
+                <a:spcPct val="90000"/>
+              </a:lnSpc>
+              <a:spcBef>
+                <a:spcPts val="0"/>
+              </a:spcBef>
+              <a:spcAft>
+                <a:spcPts val="0"/>
+              </a:spcAft>
+              <a:buClr>
+                <a:srgbClr val="FF0000"/>
+              </a:buClr>
+              <a:buSzPts val="2100"/>
+              <a:buFont typeface="Arial"/>
+              <a:buNone/>
+            </a:pPr>
+            <a:r>
+              <a:rPr lang="en" sz="2100" dirty="0">
+                <a:solidFill>
+                  <a:srgbClr val="FF0000"/>
+                </a:solidFill>
+                <a:latin typeface="Twentieth Century"/>
+                <a:ea typeface="Twentieth Century"/>
+                <a:cs typeface="Twentieth Century"/>
+                <a:sym typeface="Twentieth Century"/>
+              </a:rPr>
+              <a:t> ver colab autoencoder</a:t>
+            </a:r>
+            <a:endParaRPr sz="2100" dirty="0">
+              <a:solidFill>
+                <a:srgbClr val="FF0000"/>
+              </a:solidFill>
+              <a:latin typeface="Twentieth Century"/>
+              <a:ea typeface="Twentieth Century"/>
+              <a:cs typeface="Twentieth Century"/>
+              <a:sym typeface="Twentieth Century"/>
+            </a:endParaRPr>
+          </a:p>
+        </p:txBody>
+      </p:sp>
+    </p:spTree>
+  </p:cSld>
+  <p:clrMapOvr>
+    <a:masterClrMapping/>
+  </p:clrMapOvr>
+</p:sld>
+</file>
+
 <file path=ppt/slides/slide14.xml><?xml version="1.0" encoding="utf-8"?>
 <p:sld xmlns:a="http://schemas.openxmlformats.org/drawingml/2006/main" xmlns:r="http://schemas.openxmlformats.org/officeDocument/2006/relationships" xmlns:p="http://schemas.openxmlformats.org/presentationml/2006/main">
   <p:cSld>
@@ -16015,10 +16259,10 @@
       </p:sp>
       <p:pic>
         <p:nvPicPr>
-          <p:cNvPr id="3" name="Imagen 2">
+          <p:cNvPr id="16" name="Picture 15">
             <a:extLst>
               <a:ext uri="{FF2B5EF4-FFF2-40B4-BE49-F238E27FC236}">
-                <a16:creationId xmlns:a16="http://schemas.microsoft.com/office/drawing/2014/main" id="{4BB7FF96-0A4A-881B-92F2-2CDAE022ADEB}"/>
+                <a16:creationId xmlns:a16="http://schemas.microsoft.com/office/drawing/2014/main" id="{CE758913-E37A-D21E-A1F3-22919763CBC8}"/>
               </a:ext>
             </a:extLst>
           </p:cNvPr>
@@ -16029,184 +16273,27 @@
         </p:nvPicPr>
         <p:blipFill>
           <a:blip r:embed="rId3"/>
+          <a:srcRect r="49842"/>
           <a:stretch>
             <a:fillRect/>
           </a:stretch>
         </p:blipFill>
         <p:spPr>
           <a:xfrm>
-            <a:off x="6002298" y="2077947"/>
-            <a:ext cx="2880000" cy="2519999"/>
+            <a:off x="124226" y="656192"/>
+            <a:ext cx="6149641" cy="2402784"/>
           </a:xfrm>
           <a:prstGeom prst="rect">
             <a:avLst/>
           </a:prstGeom>
         </p:spPr>
       </p:pic>
-      <p:sp>
-        <p:nvSpPr>
-          <p:cNvPr id="4" name="Google Shape;189;g2f19d644e1e_1_90">
+      <p:pic>
+        <p:nvPicPr>
+          <p:cNvPr id="18" name="Picture 17">
             <a:extLst>
               <a:ext uri="{FF2B5EF4-FFF2-40B4-BE49-F238E27FC236}">
-                <a16:creationId xmlns:a16="http://schemas.microsoft.com/office/drawing/2014/main" id="{5B839E1E-554B-65AC-A7C3-85FFDAB7A83F}"/>
-              </a:ext>
-            </a:extLst>
-          </p:cNvPr>
-          <p:cNvSpPr txBox="1"/>
-          <p:nvPr/>
-        </p:nvSpPr>
-        <p:spPr>
-          <a:xfrm>
-            <a:off x="3711382" y="919166"/>
-            <a:ext cx="1598952" cy="317166"/>
-          </a:xfrm>
-          <a:prstGeom prst="rect">
-            <a:avLst/>
-          </a:prstGeom>
-          <a:noFill/>
-          <a:ln>
-            <a:noFill/>
-          </a:ln>
-        </p:spPr>
-        <p:txBody>
-          <a:bodyPr spcFirstLastPara="1" wrap="square" lIns="68575" tIns="34275" rIns="68575" bIns="34275" anchor="t" anchorCtr="0">
-            <a:noAutofit/>
-          </a:bodyPr>
-          <a:lstStyle/>
-          <a:p>
-            <a:pPr marL="0" marR="0" lvl="0" indent="0" algn="l" rtl="0">
-              <a:lnSpc>
-                <a:spcPct val="90000"/>
-              </a:lnSpc>
-              <a:spcBef>
-                <a:spcPts val="0"/>
-              </a:spcBef>
-              <a:spcAft>
-                <a:spcPts val="0"/>
-              </a:spcAft>
-              <a:buClr>
-                <a:srgbClr val="FF0000"/>
-              </a:buClr>
-              <a:buSzPts val="2100"/>
-              <a:buFont typeface="Arial"/>
-              <a:buNone/>
-            </a:pPr>
-            <a:r>
-              <a:rPr lang="es-AR" sz="2100" dirty="0" err="1">
-                <a:solidFill>
-                  <a:srgbClr val="FF0000"/>
-                </a:solidFill>
-                <a:latin typeface="Twentieth Century"/>
-                <a:ea typeface="Twentieth Century"/>
-                <a:cs typeface="Twentieth Century"/>
-                <a:sym typeface="Twentieth Century"/>
-              </a:rPr>
-              <a:t>sparse</a:t>
-            </a:r>
-            <a:r>
-              <a:rPr lang="es-AR" sz="2100" dirty="0">
-                <a:solidFill>
-                  <a:srgbClr val="FF0000"/>
-                </a:solidFill>
-                <a:latin typeface="Twentieth Century"/>
-                <a:ea typeface="Twentieth Century"/>
-                <a:cs typeface="Twentieth Century"/>
-                <a:sym typeface="Twentieth Century"/>
-              </a:rPr>
-              <a:t> MLP</a:t>
-            </a:r>
-          </a:p>
-          <a:p>
-            <a:pPr marL="0" marR="0" lvl="0" indent="0" algn="l" rtl="0">
-              <a:lnSpc>
-                <a:spcPct val="90000"/>
-              </a:lnSpc>
-              <a:spcBef>
-                <a:spcPts val="0"/>
-              </a:spcBef>
-              <a:spcAft>
-                <a:spcPts val="0"/>
-              </a:spcAft>
-              <a:buClr>
-                <a:srgbClr val="FF0000"/>
-              </a:buClr>
-              <a:buSzPts val="2100"/>
-              <a:buFont typeface="Arial"/>
-              <a:buNone/>
-            </a:pPr>
-            <a:r>
-              <a:rPr lang="es-AR" sz="2100" dirty="0" err="1">
-                <a:solidFill>
-                  <a:srgbClr val="FF0000"/>
-                </a:solidFill>
-                <a:latin typeface="Twentieth Century"/>
-                <a:ea typeface="Twentieth Century"/>
-                <a:cs typeface="Twentieth Century"/>
-                <a:sym typeface="Twentieth Century"/>
-              </a:rPr>
-              <a:t>Zdim</a:t>
-            </a:r>
-            <a:r>
-              <a:rPr lang="es-AR" sz="2100" dirty="0">
-                <a:solidFill>
-                  <a:srgbClr val="FF0000"/>
-                </a:solidFill>
-                <a:latin typeface="Twentieth Century"/>
-                <a:ea typeface="Twentieth Century"/>
-                <a:cs typeface="Twentieth Century"/>
-                <a:sym typeface="Twentieth Century"/>
-              </a:rPr>
-              <a:t>: 32</a:t>
-            </a:r>
-          </a:p>
-          <a:p>
-            <a:pPr marL="0" marR="0" lvl="0" indent="0" algn="l" rtl="0">
-              <a:lnSpc>
-                <a:spcPct val="90000"/>
-              </a:lnSpc>
-              <a:spcBef>
-                <a:spcPts val="0"/>
-              </a:spcBef>
-              <a:spcAft>
-                <a:spcPts val="0"/>
-              </a:spcAft>
-              <a:buClr>
-                <a:srgbClr val="FF0000"/>
-              </a:buClr>
-              <a:buSzPts val="2100"/>
-              <a:buFont typeface="Arial"/>
-              <a:buNone/>
-            </a:pPr>
-            <a:r>
-              <a:rPr lang="es-AR" sz="2100" dirty="0">
-                <a:solidFill>
-                  <a:srgbClr val="FF0000"/>
-                </a:solidFill>
-                <a:latin typeface="Twentieth Century"/>
-                <a:ea typeface="Twentieth Century"/>
-                <a:cs typeface="Twentieth Century"/>
-                <a:sym typeface="Twentieth Century"/>
-              </a:rPr>
-              <a:t>L1: 5e-4</a:t>
-            </a:r>
-            <a:endParaRPr sz="2100" dirty="0">
-              <a:solidFill>
-                <a:srgbClr val="FF0000"/>
-              </a:solidFill>
-              <a:latin typeface="Twentieth Century"/>
-              <a:ea typeface="Twentieth Century"/>
-              <a:cs typeface="Twentieth Century"/>
-              <a:sym typeface="Twentieth Century"/>
-            </a:endParaRPr>
-          </a:p>
-        </p:txBody>
-      </p:sp>
-      <p:pic>
-        <p:nvPicPr>
-          <p:cNvPr id="6" name="Imagen 5">
-            <a:extLst>
-              <a:ext uri="{FF2B5EF4-FFF2-40B4-BE49-F238E27FC236}">
-                <a16:creationId xmlns:a16="http://schemas.microsoft.com/office/drawing/2014/main" id="{736236D8-E150-6244-93D2-BC1EEA48D45F}"/>
+                <a16:creationId xmlns:a16="http://schemas.microsoft.com/office/drawing/2014/main" id="{DE38000C-5826-28B7-2BCD-890B49B506FE}"/>
               </a:ext>
             </a:extLst>
           </p:cNvPr>
@@ -16216,492 +16303,22 @@
           <p:nvPr/>
         </p:nvPicPr>
         <p:blipFill>
-          <a:blip r:embed="rId4"/>
+          <a:blip r:embed="rId3"/>
+          <a:srcRect l="49842"/>
           <a:stretch>
             <a:fillRect/>
           </a:stretch>
         </p:blipFill>
         <p:spPr>
           <a:xfrm>
-            <a:off x="3122298" y="2112833"/>
-            <a:ext cx="2880000" cy="2520000"/>
+            <a:off x="3403735" y="2900667"/>
+            <a:ext cx="5740265" cy="2242833"/>
           </a:xfrm>
           <a:prstGeom prst="rect">
             <a:avLst/>
           </a:prstGeom>
         </p:spPr>
       </p:pic>
-      <p:sp>
-        <p:nvSpPr>
-          <p:cNvPr id="7" name="Google Shape;189;g2f19d644e1e_1_90">
-            <a:extLst>
-              <a:ext uri="{FF2B5EF4-FFF2-40B4-BE49-F238E27FC236}">
-                <a16:creationId xmlns:a16="http://schemas.microsoft.com/office/drawing/2014/main" id="{BEE56B23-341F-DBD7-E8DA-372DDE715C9E}"/>
-              </a:ext>
-            </a:extLst>
-          </p:cNvPr>
-          <p:cNvSpPr txBox="1"/>
-          <p:nvPr/>
-        </p:nvSpPr>
-        <p:spPr>
-          <a:xfrm>
-            <a:off x="6850727" y="996318"/>
-            <a:ext cx="1598952" cy="317166"/>
-          </a:xfrm>
-          <a:prstGeom prst="rect">
-            <a:avLst/>
-          </a:prstGeom>
-          <a:noFill/>
-          <a:ln>
-            <a:noFill/>
-          </a:ln>
-        </p:spPr>
-        <p:txBody>
-          <a:bodyPr spcFirstLastPara="1" wrap="square" lIns="68575" tIns="34275" rIns="68575" bIns="34275" anchor="t" anchorCtr="0">
-            <a:noAutofit/>
-          </a:bodyPr>
-          <a:lstStyle/>
-          <a:p>
-            <a:pPr marL="0" marR="0" lvl="0" indent="0" algn="l" rtl="0">
-              <a:lnSpc>
-                <a:spcPct val="90000"/>
-              </a:lnSpc>
-              <a:spcBef>
-                <a:spcPts val="0"/>
-              </a:spcBef>
-              <a:spcAft>
-                <a:spcPts val="0"/>
-              </a:spcAft>
-              <a:buClr>
-                <a:srgbClr val="FF0000"/>
-              </a:buClr>
-              <a:buSzPts val="2100"/>
-              <a:buFont typeface="Arial"/>
-              <a:buNone/>
-            </a:pPr>
-            <a:r>
-              <a:rPr lang="es-AR" sz="2100" dirty="0">
-                <a:solidFill>
-                  <a:srgbClr val="FF0000"/>
-                </a:solidFill>
-                <a:latin typeface="Twentieth Century"/>
-                <a:ea typeface="Twentieth Century"/>
-                <a:cs typeface="Twentieth Century"/>
-                <a:sym typeface="Twentieth Century"/>
-              </a:rPr>
-              <a:t>VAE MLP</a:t>
-            </a:r>
-          </a:p>
-          <a:p>
-            <a:pPr marL="0" marR="0" lvl="0" indent="0" algn="l" rtl="0">
-              <a:lnSpc>
-                <a:spcPct val="90000"/>
-              </a:lnSpc>
-              <a:spcBef>
-                <a:spcPts val="0"/>
-              </a:spcBef>
-              <a:spcAft>
-                <a:spcPts val="0"/>
-              </a:spcAft>
-              <a:buClr>
-                <a:srgbClr val="FF0000"/>
-              </a:buClr>
-              <a:buSzPts val="2100"/>
-              <a:buFont typeface="Arial"/>
-              <a:buNone/>
-            </a:pPr>
-            <a:r>
-              <a:rPr lang="es-AR" sz="2100" dirty="0" err="1">
-                <a:solidFill>
-                  <a:srgbClr val="FF0000"/>
-                </a:solidFill>
-                <a:latin typeface="Twentieth Century"/>
-                <a:ea typeface="Twentieth Century"/>
-                <a:cs typeface="Twentieth Century"/>
-                <a:sym typeface="Twentieth Century"/>
-              </a:rPr>
-              <a:t>Zdim</a:t>
-            </a:r>
-            <a:r>
-              <a:rPr lang="es-AR" sz="2100" dirty="0">
-                <a:solidFill>
-                  <a:srgbClr val="FF0000"/>
-                </a:solidFill>
-                <a:latin typeface="Twentieth Century"/>
-                <a:ea typeface="Twentieth Century"/>
-                <a:cs typeface="Twentieth Century"/>
-                <a:sym typeface="Twentieth Century"/>
-              </a:rPr>
-              <a:t>: 32</a:t>
-            </a:r>
-          </a:p>
-          <a:p>
-            <a:pPr marL="0" marR="0" lvl="0" indent="0" algn="l" rtl="0">
-              <a:lnSpc>
-                <a:spcPct val="90000"/>
-              </a:lnSpc>
-              <a:spcBef>
-                <a:spcPts val="0"/>
-              </a:spcBef>
-              <a:spcAft>
-                <a:spcPts val="0"/>
-              </a:spcAft>
-              <a:buClr>
-                <a:srgbClr val="FF0000"/>
-              </a:buClr>
-              <a:buSzPts val="2100"/>
-              <a:buFont typeface="Arial"/>
-              <a:buNone/>
-            </a:pPr>
-            <a:r>
-              <a:rPr lang="es-AR" sz="2100" dirty="0">
-                <a:solidFill>
-                  <a:srgbClr val="FF0000"/>
-                </a:solidFill>
-                <a:latin typeface="Twentieth Century"/>
-                <a:ea typeface="Twentieth Century"/>
-                <a:cs typeface="Twentieth Century"/>
-                <a:sym typeface="Twentieth Century"/>
-              </a:rPr>
-              <a:t>Kl: 1e-4</a:t>
-            </a:r>
-            <a:endParaRPr sz="2100" dirty="0">
-              <a:solidFill>
-                <a:srgbClr val="FF0000"/>
-              </a:solidFill>
-              <a:latin typeface="Twentieth Century"/>
-              <a:ea typeface="Twentieth Century"/>
-              <a:cs typeface="Twentieth Century"/>
-              <a:sym typeface="Twentieth Century"/>
-            </a:endParaRPr>
-          </a:p>
-        </p:txBody>
-      </p:sp>
-      <p:pic>
-        <p:nvPicPr>
-          <p:cNvPr id="9" name="Imagen 8">
-            <a:extLst>
-              <a:ext uri="{FF2B5EF4-FFF2-40B4-BE49-F238E27FC236}">
-                <a16:creationId xmlns:a16="http://schemas.microsoft.com/office/drawing/2014/main" id="{01DD52B7-6D92-C044-AFBB-50DB34546169}"/>
-              </a:ext>
-            </a:extLst>
-          </p:cNvPr>
-          <p:cNvPicPr>
-            <a:picLocks noChangeAspect="1"/>
-          </p:cNvPicPr>
-          <p:nvPr/>
-        </p:nvPicPr>
-        <p:blipFill>
-          <a:blip r:embed="rId5"/>
-          <a:stretch>
-            <a:fillRect/>
-          </a:stretch>
-        </p:blipFill>
-        <p:spPr>
-          <a:xfrm>
-            <a:off x="147816" y="2112833"/>
-            <a:ext cx="2880000" cy="2520000"/>
-          </a:xfrm>
-          <a:prstGeom prst="rect">
-            <a:avLst/>
-          </a:prstGeom>
-        </p:spPr>
-      </p:pic>
-      <p:sp>
-        <p:nvSpPr>
-          <p:cNvPr id="10" name="Google Shape;189;g2f19d644e1e_1_90">
-            <a:extLst>
-              <a:ext uri="{FF2B5EF4-FFF2-40B4-BE49-F238E27FC236}">
-                <a16:creationId xmlns:a16="http://schemas.microsoft.com/office/drawing/2014/main" id="{5C64B54E-77D2-53F4-ED48-4839DF7770D9}"/>
-              </a:ext>
-            </a:extLst>
-          </p:cNvPr>
-          <p:cNvSpPr txBox="1"/>
-          <p:nvPr/>
-        </p:nvSpPr>
-        <p:spPr>
-          <a:xfrm>
-            <a:off x="694321" y="970474"/>
-            <a:ext cx="1598952" cy="317166"/>
-          </a:xfrm>
-          <a:prstGeom prst="rect">
-            <a:avLst/>
-          </a:prstGeom>
-          <a:noFill/>
-          <a:ln>
-            <a:noFill/>
-          </a:ln>
-        </p:spPr>
-        <p:txBody>
-          <a:bodyPr spcFirstLastPara="1" wrap="square" lIns="68575" tIns="34275" rIns="68575" bIns="34275" anchor="t" anchorCtr="0">
-            <a:noAutofit/>
-          </a:bodyPr>
-          <a:lstStyle/>
-          <a:p>
-            <a:pPr marL="0" marR="0" lvl="0" indent="0" algn="l" rtl="0">
-              <a:lnSpc>
-                <a:spcPct val="90000"/>
-              </a:lnSpc>
-              <a:spcBef>
-                <a:spcPts val="0"/>
-              </a:spcBef>
-              <a:spcAft>
-                <a:spcPts val="0"/>
-              </a:spcAft>
-              <a:buClr>
-                <a:srgbClr val="FF0000"/>
-              </a:buClr>
-              <a:buSzPts val="2100"/>
-              <a:buFont typeface="Arial"/>
-              <a:buNone/>
-            </a:pPr>
-            <a:r>
-              <a:rPr lang="es-AR" sz="2100" dirty="0">
-                <a:solidFill>
-                  <a:srgbClr val="FF0000"/>
-                </a:solidFill>
-                <a:latin typeface="Twentieth Century"/>
-                <a:ea typeface="Twentieth Century"/>
-                <a:cs typeface="Twentieth Century"/>
-                <a:sym typeface="Twentieth Century"/>
-              </a:rPr>
-              <a:t>MLP</a:t>
-            </a:r>
-          </a:p>
-          <a:p>
-            <a:pPr marL="0" marR="0" lvl="0" indent="0" algn="l" rtl="0">
-              <a:lnSpc>
-                <a:spcPct val="90000"/>
-              </a:lnSpc>
-              <a:spcBef>
-                <a:spcPts val="0"/>
-              </a:spcBef>
-              <a:spcAft>
-                <a:spcPts val="0"/>
-              </a:spcAft>
-              <a:buClr>
-                <a:srgbClr val="FF0000"/>
-              </a:buClr>
-              <a:buSzPts val="2100"/>
-              <a:buFont typeface="Arial"/>
-              <a:buNone/>
-            </a:pPr>
-            <a:r>
-              <a:rPr lang="es-AR" sz="2100" dirty="0" err="1">
-                <a:solidFill>
-                  <a:srgbClr val="FF0000"/>
-                </a:solidFill>
-                <a:latin typeface="Twentieth Century"/>
-                <a:ea typeface="Twentieth Century"/>
-                <a:cs typeface="Twentieth Century"/>
-                <a:sym typeface="Twentieth Century"/>
-              </a:rPr>
-              <a:t>Zdim</a:t>
-            </a:r>
-            <a:r>
-              <a:rPr lang="es-AR" sz="2100" dirty="0">
-                <a:solidFill>
-                  <a:srgbClr val="FF0000"/>
-                </a:solidFill>
-                <a:latin typeface="Twentieth Century"/>
-                <a:ea typeface="Twentieth Century"/>
-                <a:cs typeface="Twentieth Century"/>
-                <a:sym typeface="Twentieth Century"/>
-              </a:rPr>
-              <a:t>: 32</a:t>
-            </a:r>
-          </a:p>
-        </p:txBody>
-      </p:sp>
-      <p:sp>
-        <p:nvSpPr>
-          <p:cNvPr id="11" name="Google Shape;189;g2f19d644e1e_1_90">
-            <a:extLst>
-              <a:ext uri="{FF2B5EF4-FFF2-40B4-BE49-F238E27FC236}">
-                <a16:creationId xmlns:a16="http://schemas.microsoft.com/office/drawing/2014/main" id="{245BCB9B-BC5E-A8D9-B15C-291C94FEC326}"/>
-              </a:ext>
-            </a:extLst>
-          </p:cNvPr>
-          <p:cNvSpPr txBox="1"/>
-          <p:nvPr/>
-        </p:nvSpPr>
-        <p:spPr>
-          <a:xfrm>
-            <a:off x="788340" y="4691096"/>
-            <a:ext cx="1598952" cy="317166"/>
-          </a:xfrm>
-          <a:prstGeom prst="rect">
-            <a:avLst/>
-          </a:prstGeom>
-          <a:noFill/>
-          <a:ln>
-            <a:noFill/>
-          </a:ln>
-        </p:spPr>
-        <p:txBody>
-          <a:bodyPr spcFirstLastPara="1" wrap="square" lIns="68575" tIns="34275" rIns="68575" bIns="34275" anchor="t" anchorCtr="0">
-            <a:noAutofit/>
-          </a:bodyPr>
-          <a:lstStyle/>
-          <a:p>
-            <a:pPr marL="0" marR="0" lvl="0" indent="0" algn="l" rtl="0">
-              <a:lnSpc>
-                <a:spcPct val="90000"/>
-              </a:lnSpc>
-              <a:spcBef>
-                <a:spcPts val="0"/>
-              </a:spcBef>
-              <a:spcAft>
-                <a:spcPts val="0"/>
-              </a:spcAft>
-              <a:buClr>
-                <a:srgbClr val="FF0000"/>
-              </a:buClr>
-              <a:buSzPts val="2100"/>
-              <a:buFont typeface="Arial"/>
-              <a:buNone/>
-            </a:pPr>
-            <a:r>
-              <a:rPr lang="es-AR" sz="2100" dirty="0">
-                <a:solidFill>
-                  <a:srgbClr val="FF0000"/>
-                </a:solidFill>
-                <a:latin typeface="Twentieth Century"/>
-                <a:ea typeface="Twentieth Century"/>
-                <a:cs typeface="Twentieth Century"/>
-                <a:sym typeface="Twentieth Century"/>
-              </a:rPr>
-              <a:t>MSE: 0.0431</a:t>
-            </a:r>
-          </a:p>
-        </p:txBody>
-      </p:sp>
-      <p:sp>
-        <p:nvSpPr>
-          <p:cNvPr id="12" name="Google Shape;189;g2f19d644e1e_1_90">
-            <a:extLst>
-              <a:ext uri="{FF2B5EF4-FFF2-40B4-BE49-F238E27FC236}">
-                <a16:creationId xmlns:a16="http://schemas.microsoft.com/office/drawing/2014/main" id="{B9315433-840C-5FED-1729-50367699B95C}"/>
-              </a:ext>
-            </a:extLst>
-          </p:cNvPr>
-          <p:cNvSpPr txBox="1"/>
-          <p:nvPr/>
-        </p:nvSpPr>
-        <p:spPr>
-          <a:xfrm>
-            <a:off x="3772524" y="4656130"/>
-            <a:ext cx="1598952" cy="317166"/>
-          </a:xfrm>
-          <a:prstGeom prst="rect">
-            <a:avLst/>
-          </a:prstGeom>
-          <a:noFill/>
-          <a:ln>
-            <a:noFill/>
-          </a:ln>
-        </p:spPr>
-        <p:txBody>
-          <a:bodyPr spcFirstLastPara="1" wrap="square" lIns="68575" tIns="34275" rIns="68575" bIns="34275" anchor="t" anchorCtr="0">
-            <a:noAutofit/>
-          </a:bodyPr>
-          <a:lstStyle/>
-          <a:p>
-            <a:pPr marL="0" marR="0" lvl="0" indent="0" algn="l" rtl="0">
-              <a:lnSpc>
-                <a:spcPct val="90000"/>
-              </a:lnSpc>
-              <a:spcBef>
-                <a:spcPts val="0"/>
-              </a:spcBef>
-              <a:spcAft>
-                <a:spcPts val="0"/>
-              </a:spcAft>
-              <a:buClr>
-                <a:srgbClr val="FF0000"/>
-              </a:buClr>
-              <a:buSzPts val="2100"/>
-              <a:buFont typeface="Arial"/>
-              <a:buNone/>
-            </a:pPr>
-            <a:r>
-              <a:rPr lang="es-AR" sz="2100" dirty="0">
-                <a:solidFill>
-                  <a:srgbClr val="FF0000"/>
-                </a:solidFill>
-                <a:latin typeface="Twentieth Century"/>
-                <a:ea typeface="Twentieth Century"/>
-                <a:cs typeface="Twentieth Century"/>
-                <a:sym typeface="Twentieth Century"/>
-              </a:rPr>
-              <a:t>MSE: 0.0457</a:t>
-            </a:r>
-          </a:p>
-        </p:txBody>
-      </p:sp>
-      <p:sp>
-        <p:nvSpPr>
-          <p:cNvPr id="13" name="Google Shape;189;g2f19d644e1e_1_90">
-            <a:extLst>
-              <a:ext uri="{FF2B5EF4-FFF2-40B4-BE49-F238E27FC236}">
-                <a16:creationId xmlns:a16="http://schemas.microsoft.com/office/drawing/2014/main" id="{3AECCDD5-CA7D-1C2A-6F6E-498E4B0AFE57}"/>
-              </a:ext>
-            </a:extLst>
-          </p:cNvPr>
-          <p:cNvSpPr txBox="1"/>
-          <p:nvPr/>
-        </p:nvSpPr>
-        <p:spPr>
-          <a:xfrm>
-            <a:off x="6588054" y="4597946"/>
-            <a:ext cx="1598952" cy="317166"/>
-          </a:xfrm>
-          <a:prstGeom prst="rect">
-            <a:avLst/>
-          </a:prstGeom>
-          <a:noFill/>
-          <a:ln>
-            <a:noFill/>
-          </a:ln>
-        </p:spPr>
-        <p:txBody>
-          <a:bodyPr spcFirstLastPara="1" wrap="square" lIns="68575" tIns="34275" rIns="68575" bIns="34275" anchor="t" anchorCtr="0">
-            <a:noAutofit/>
-          </a:bodyPr>
-          <a:lstStyle/>
-          <a:p>
-            <a:pPr marL="0" marR="0" lvl="0" indent="0" algn="l" rtl="0">
-              <a:lnSpc>
-                <a:spcPct val="90000"/>
-              </a:lnSpc>
-              <a:spcBef>
-                <a:spcPts val="0"/>
-              </a:spcBef>
-              <a:spcAft>
-                <a:spcPts val="0"/>
-              </a:spcAft>
-              <a:buClr>
-                <a:srgbClr val="FF0000"/>
-              </a:buClr>
-              <a:buSzPts val="2100"/>
-              <a:buFont typeface="Arial"/>
-              <a:buNone/>
-            </a:pPr>
-            <a:r>
-              <a:rPr lang="es-AR" sz="2100" dirty="0">
-                <a:solidFill>
-                  <a:srgbClr val="FF0000"/>
-                </a:solidFill>
-                <a:latin typeface="Twentieth Century"/>
-                <a:ea typeface="Twentieth Century"/>
-                <a:cs typeface="Twentieth Century"/>
-                <a:sym typeface="Twentieth Century"/>
-              </a:rPr>
-              <a:t>MSE: 0.0440</a:t>
-            </a:r>
-          </a:p>
-        </p:txBody>
-      </p:sp>
     </p:spTree>
     <p:extLst>
       <p:ext uri="{BB962C8B-B14F-4D97-AF65-F5344CB8AC3E}">
@@ -16812,10 +16429,10 @@
       </p:sp>
       <p:sp>
         <p:nvSpPr>
-          <p:cNvPr id="4" name="Google Shape;189;g2f19d644e1e_1_90">
+          <p:cNvPr id="11" name="Google Shape;189;g2f19d644e1e_1_90">
             <a:extLst>
               <a:ext uri="{FF2B5EF4-FFF2-40B4-BE49-F238E27FC236}">
-                <a16:creationId xmlns:a16="http://schemas.microsoft.com/office/drawing/2014/main" id="{C0AD1CD5-313C-8345-35E1-EE490B62DE69}"/>
+                <a16:creationId xmlns:a16="http://schemas.microsoft.com/office/drawing/2014/main" id="{720055BD-D7D0-FC30-865A-55AA61DE09DC}"/>
               </a:ext>
             </a:extLst>
           </p:cNvPr>
@@ -16824,8 +16441,8 @@
         </p:nvSpPr>
         <p:spPr>
           <a:xfrm>
-            <a:off x="3711382" y="919166"/>
-            <a:ext cx="1598952" cy="317166"/>
+            <a:off x="7085495" y="1930794"/>
+            <a:ext cx="1955503" cy="317166"/>
           </a:xfrm>
           <a:prstGeom prst="rect">
             <a:avLst/>
@@ -16859,7 +16476,7 @@
               <a:buNone/>
             </a:pPr>
             <a:r>
-              <a:rPr lang="es-AR" sz="2100" dirty="0" err="1">
+              <a:rPr lang="es-AR" sz="2100" dirty="0">
                 <a:solidFill>
                   <a:srgbClr val="FF0000"/>
                 </a:solidFill>
@@ -16868,417 +16485,7 @@
                 <a:cs typeface="Twentieth Century"/>
                 <a:sym typeface="Twentieth Century"/>
               </a:rPr>
-              <a:t>sparse</a:t>
-            </a:r>
-            <a:r>
-              <a:rPr lang="es-AR" sz="2100" dirty="0">
-                <a:solidFill>
-                  <a:srgbClr val="FF0000"/>
-                </a:solidFill>
-                <a:latin typeface="Twentieth Century"/>
-                <a:ea typeface="Twentieth Century"/>
-                <a:cs typeface="Twentieth Century"/>
-                <a:sym typeface="Twentieth Century"/>
-              </a:rPr>
-              <a:t> MLP</a:t>
-            </a:r>
-          </a:p>
-          <a:p>
-            <a:pPr marL="0" marR="0" lvl="0" indent="0" algn="l" rtl="0">
-              <a:lnSpc>
-                <a:spcPct val="90000"/>
-              </a:lnSpc>
-              <a:spcBef>
-                <a:spcPts val="0"/>
-              </a:spcBef>
-              <a:spcAft>
-                <a:spcPts val="0"/>
-              </a:spcAft>
-              <a:buClr>
-                <a:srgbClr val="FF0000"/>
-              </a:buClr>
-              <a:buSzPts val="2100"/>
-              <a:buFont typeface="Arial"/>
-              <a:buNone/>
-            </a:pPr>
-            <a:r>
-              <a:rPr lang="es-AR" sz="2100" dirty="0" err="1">
-                <a:solidFill>
-                  <a:srgbClr val="FF0000"/>
-                </a:solidFill>
-                <a:latin typeface="Twentieth Century"/>
-                <a:ea typeface="Twentieth Century"/>
-                <a:cs typeface="Twentieth Century"/>
-                <a:sym typeface="Twentieth Century"/>
-              </a:rPr>
-              <a:t>Zdim</a:t>
-            </a:r>
-            <a:r>
-              <a:rPr lang="es-AR" sz="2100" dirty="0">
-                <a:solidFill>
-                  <a:srgbClr val="FF0000"/>
-                </a:solidFill>
-                <a:latin typeface="Twentieth Century"/>
-                <a:ea typeface="Twentieth Century"/>
-                <a:cs typeface="Twentieth Century"/>
-                <a:sym typeface="Twentieth Century"/>
-              </a:rPr>
-              <a:t>: 32</a:t>
-            </a:r>
-          </a:p>
-          <a:p>
-            <a:pPr marL="0" marR="0" lvl="0" indent="0" algn="l" rtl="0">
-              <a:lnSpc>
-                <a:spcPct val="90000"/>
-              </a:lnSpc>
-              <a:spcBef>
-                <a:spcPts val="0"/>
-              </a:spcBef>
-              <a:spcAft>
-                <a:spcPts val="0"/>
-              </a:spcAft>
-              <a:buClr>
-                <a:srgbClr val="FF0000"/>
-              </a:buClr>
-              <a:buSzPts val="2100"/>
-              <a:buFont typeface="Arial"/>
-              <a:buNone/>
-            </a:pPr>
-            <a:r>
-              <a:rPr lang="es-AR" sz="2100" dirty="0">
-                <a:solidFill>
-                  <a:srgbClr val="FF0000"/>
-                </a:solidFill>
-                <a:latin typeface="Twentieth Century"/>
-                <a:ea typeface="Twentieth Century"/>
-                <a:cs typeface="Twentieth Century"/>
-                <a:sym typeface="Twentieth Century"/>
-              </a:rPr>
-              <a:t>L1: 5e-4</a:t>
-            </a:r>
-            <a:endParaRPr sz="2100" dirty="0">
-              <a:solidFill>
-                <a:srgbClr val="FF0000"/>
-              </a:solidFill>
-              <a:latin typeface="Twentieth Century"/>
-              <a:ea typeface="Twentieth Century"/>
-              <a:cs typeface="Twentieth Century"/>
-              <a:sym typeface="Twentieth Century"/>
-            </a:endParaRPr>
-          </a:p>
-        </p:txBody>
-      </p:sp>
-      <p:sp>
-        <p:nvSpPr>
-          <p:cNvPr id="7" name="Google Shape;189;g2f19d644e1e_1_90">
-            <a:extLst>
-              <a:ext uri="{FF2B5EF4-FFF2-40B4-BE49-F238E27FC236}">
-                <a16:creationId xmlns:a16="http://schemas.microsoft.com/office/drawing/2014/main" id="{157AADA2-0864-34B0-682A-FC33B129A56A}"/>
-              </a:ext>
-            </a:extLst>
-          </p:cNvPr>
-          <p:cNvSpPr txBox="1"/>
-          <p:nvPr/>
-        </p:nvSpPr>
-        <p:spPr>
-          <a:xfrm>
-            <a:off x="6850727" y="996318"/>
-            <a:ext cx="1598952" cy="317166"/>
-          </a:xfrm>
-          <a:prstGeom prst="rect">
-            <a:avLst/>
-          </a:prstGeom>
-          <a:noFill/>
-          <a:ln>
-            <a:noFill/>
-          </a:ln>
-        </p:spPr>
-        <p:txBody>
-          <a:bodyPr spcFirstLastPara="1" wrap="square" lIns="68575" tIns="34275" rIns="68575" bIns="34275" anchor="t" anchorCtr="0">
-            <a:noAutofit/>
-          </a:bodyPr>
-          <a:lstStyle/>
-          <a:p>
-            <a:pPr marL="0" marR="0" lvl="0" indent="0" algn="l" rtl="0">
-              <a:lnSpc>
-                <a:spcPct val="90000"/>
-              </a:lnSpc>
-              <a:spcBef>
-                <a:spcPts val="0"/>
-              </a:spcBef>
-              <a:spcAft>
-                <a:spcPts val="0"/>
-              </a:spcAft>
-              <a:buClr>
-                <a:srgbClr val="FF0000"/>
-              </a:buClr>
-              <a:buSzPts val="2100"/>
-              <a:buFont typeface="Arial"/>
-              <a:buNone/>
-            </a:pPr>
-            <a:r>
-              <a:rPr lang="es-AR" sz="2100" dirty="0">
-                <a:solidFill>
-                  <a:srgbClr val="FF0000"/>
-                </a:solidFill>
-                <a:latin typeface="Twentieth Century"/>
-                <a:ea typeface="Twentieth Century"/>
-                <a:cs typeface="Twentieth Century"/>
-                <a:sym typeface="Twentieth Century"/>
-              </a:rPr>
-              <a:t>VAE MLP</a:t>
-            </a:r>
-          </a:p>
-          <a:p>
-            <a:pPr marL="0" marR="0" lvl="0" indent="0" algn="l" rtl="0">
-              <a:lnSpc>
-                <a:spcPct val="90000"/>
-              </a:lnSpc>
-              <a:spcBef>
-                <a:spcPts val="0"/>
-              </a:spcBef>
-              <a:spcAft>
-                <a:spcPts val="0"/>
-              </a:spcAft>
-              <a:buClr>
-                <a:srgbClr val="FF0000"/>
-              </a:buClr>
-              <a:buSzPts val="2100"/>
-              <a:buFont typeface="Arial"/>
-              <a:buNone/>
-            </a:pPr>
-            <a:r>
-              <a:rPr lang="es-AR" sz="2100" dirty="0" err="1">
-                <a:solidFill>
-                  <a:srgbClr val="FF0000"/>
-                </a:solidFill>
-                <a:latin typeface="Twentieth Century"/>
-                <a:ea typeface="Twentieth Century"/>
-                <a:cs typeface="Twentieth Century"/>
-                <a:sym typeface="Twentieth Century"/>
-              </a:rPr>
-              <a:t>Zdim</a:t>
-            </a:r>
-            <a:r>
-              <a:rPr lang="es-AR" sz="2100" dirty="0">
-                <a:solidFill>
-                  <a:srgbClr val="FF0000"/>
-                </a:solidFill>
-                <a:latin typeface="Twentieth Century"/>
-                <a:ea typeface="Twentieth Century"/>
-                <a:cs typeface="Twentieth Century"/>
-                <a:sym typeface="Twentieth Century"/>
-              </a:rPr>
-              <a:t>: 32</a:t>
-            </a:r>
-          </a:p>
-          <a:p>
-            <a:pPr marL="0" marR="0" lvl="0" indent="0" algn="l" rtl="0">
-              <a:lnSpc>
-                <a:spcPct val="90000"/>
-              </a:lnSpc>
-              <a:spcBef>
-                <a:spcPts val="0"/>
-              </a:spcBef>
-              <a:spcAft>
-                <a:spcPts val="0"/>
-              </a:spcAft>
-              <a:buClr>
-                <a:srgbClr val="FF0000"/>
-              </a:buClr>
-              <a:buSzPts val="2100"/>
-              <a:buFont typeface="Arial"/>
-              <a:buNone/>
-            </a:pPr>
-            <a:r>
-              <a:rPr lang="es-AR" sz="2100" dirty="0">
-                <a:solidFill>
-                  <a:srgbClr val="FF0000"/>
-                </a:solidFill>
-                <a:latin typeface="Twentieth Century"/>
-                <a:ea typeface="Twentieth Century"/>
-                <a:cs typeface="Twentieth Century"/>
-                <a:sym typeface="Twentieth Century"/>
-              </a:rPr>
-              <a:t>Kl: 1e-4</a:t>
-            </a:r>
-            <a:endParaRPr sz="2100" dirty="0">
-              <a:solidFill>
-                <a:srgbClr val="FF0000"/>
-              </a:solidFill>
-              <a:latin typeface="Twentieth Century"/>
-              <a:ea typeface="Twentieth Century"/>
-              <a:cs typeface="Twentieth Century"/>
-              <a:sym typeface="Twentieth Century"/>
-            </a:endParaRPr>
-          </a:p>
-        </p:txBody>
-      </p:sp>
-      <p:sp>
-        <p:nvSpPr>
-          <p:cNvPr id="10" name="Google Shape;189;g2f19d644e1e_1_90">
-            <a:extLst>
-              <a:ext uri="{FF2B5EF4-FFF2-40B4-BE49-F238E27FC236}">
-                <a16:creationId xmlns:a16="http://schemas.microsoft.com/office/drawing/2014/main" id="{38743EAC-28CD-9FA0-BECC-C083B56EC437}"/>
-              </a:ext>
-            </a:extLst>
-          </p:cNvPr>
-          <p:cNvSpPr txBox="1"/>
-          <p:nvPr/>
-        </p:nvSpPr>
-        <p:spPr>
-          <a:xfrm>
-            <a:off x="694321" y="970474"/>
-            <a:ext cx="1598952" cy="317166"/>
-          </a:xfrm>
-          <a:prstGeom prst="rect">
-            <a:avLst/>
-          </a:prstGeom>
-          <a:noFill/>
-          <a:ln>
-            <a:noFill/>
-          </a:ln>
-        </p:spPr>
-        <p:txBody>
-          <a:bodyPr spcFirstLastPara="1" wrap="square" lIns="68575" tIns="34275" rIns="68575" bIns="34275" anchor="t" anchorCtr="0">
-            <a:noAutofit/>
-          </a:bodyPr>
-          <a:lstStyle/>
-          <a:p>
-            <a:pPr marL="0" marR="0" lvl="0" indent="0" algn="l" rtl="0">
-              <a:lnSpc>
-                <a:spcPct val="90000"/>
-              </a:lnSpc>
-              <a:spcBef>
-                <a:spcPts val="0"/>
-              </a:spcBef>
-              <a:spcAft>
-                <a:spcPts val="0"/>
-              </a:spcAft>
-              <a:buClr>
-                <a:srgbClr val="FF0000"/>
-              </a:buClr>
-              <a:buSzPts val="2100"/>
-              <a:buFont typeface="Arial"/>
-              <a:buNone/>
-            </a:pPr>
-            <a:r>
-              <a:rPr lang="es-AR" sz="2100" dirty="0">
-                <a:solidFill>
-                  <a:srgbClr val="FF0000"/>
-                </a:solidFill>
-                <a:latin typeface="Twentieth Century"/>
-                <a:ea typeface="Twentieth Century"/>
-                <a:cs typeface="Twentieth Century"/>
-                <a:sym typeface="Twentieth Century"/>
-              </a:rPr>
-              <a:t>MLP</a:t>
-            </a:r>
-          </a:p>
-          <a:p>
-            <a:pPr marL="0" marR="0" lvl="0" indent="0" algn="l" rtl="0">
-              <a:lnSpc>
-                <a:spcPct val="90000"/>
-              </a:lnSpc>
-              <a:spcBef>
-                <a:spcPts val="0"/>
-              </a:spcBef>
-              <a:spcAft>
-                <a:spcPts val="0"/>
-              </a:spcAft>
-              <a:buClr>
-                <a:srgbClr val="FF0000"/>
-              </a:buClr>
-              <a:buSzPts val="2100"/>
-              <a:buFont typeface="Arial"/>
-              <a:buNone/>
-            </a:pPr>
-            <a:r>
-              <a:rPr lang="es-AR" sz="2100" dirty="0" err="1">
-                <a:solidFill>
-                  <a:srgbClr val="FF0000"/>
-                </a:solidFill>
-                <a:latin typeface="Twentieth Century"/>
-                <a:ea typeface="Twentieth Century"/>
-                <a:cs typeface="Twentieth Century"/>
-                <a:sym typeface="Twentieth Century"/>
-              </a:rPr>
-              <a:t>Zdim</a:t>
-            </a:r>
-            <a:r>
-              <a:rPr lang="es-AR" sz="2100" dirty="0">
-                <a:solidFill>
-                  <a:srgbClr val="FF0000"/>
-                </a:solidFill>
-                <a:latin typeface="Twentieth Century"/>
-                <a:ea typeface="Twentieth Century"/>
-                <a:cs typeface="Twentieth Century"/>
-                <a:sym typeface="Twentieth Century"/>
-              </a:rPr>
-              <a:t>: 32</a:t>
-            </a:r>
-          </a:p>
-        </p:txBody>
-      </p:sp>
-      <p:sp>
-        <p:nvSpPr>
-          <p:cNvPr id="11" name="Google Shape;189;g2f19d644e1e_1_90">
-            <a:extLst>
-              <a:ext uri="{FF2B5EF4-FFF2-40B4-BE49-F238E27FC236}">
-                <a16:creationId xmlns:a16="http://schemas.microsoft.com/office/drawing/2014/main" id="{720055BD-D7D0-FC30-865A-55AA61DE09DC}"/>
-              </a:ext>
-            </a:extLst>
-          </p:cNvPr>
-          <p:cNvSpPr txBox="1"/>
-          <p:nvPr/>
-        </p:nvSpPr>
-        <p:spPr>
-          <a:xfrm>
-            <a:off x="788340" y="4691096"/>
-            <a:ext cx="1598952" cy="317166"/>
-          </a:xfrm>
-          <a:prstGeom prst="rect">
-            <a:avLst/>
-          </a:prstGeom>
-          <a:noFill/>
-          <a:ln>
-            <a:noFill/>
-          </a:ln>
-        </p:spPr>
-        <p:txBody>
-          <a:bodyPr spcFirstLastPara="1" wrap="square" lIns="68575" tIns="34275" rIns="68575" bIns="34275" anchor="t" anchorCtr="0">
-            <a:noAutofit/>
-          </a:bodyPr>
-          <a:lstStyle/>
-          <a:p>
-            <a:pPr marL="0" marR="0" lvl="0" indent="0" algn="l" rtl="0">
-              <a:lnSpc>
-                <a:spcPct val="90000"/>
-              </a:lnSpc>
-              <a:spcBef>
-                <a:spcPts val="0"/>
-              </a:spcBef>
-              <a:spcAft>
-                <a:spcPts val="0"/>
-              </a:spcAft>
-              <a:buClr>
-                <a:srgbClr val="FF0000"/>
-              </a:buClr>
-              <a:buSzPts val="2100"/>
-              <a:buFont typeface="Arial"/>
-              <a:buNone/>
-            </a:pPr>
-            <a:r>
-              <a:rPr lang="es-AR" sz="2100" dirty="0">
-                <a:solidFill>
-                  <a:srgbClr val="FF0000"/>
-                </a:solidFill>
-                <a:latin typeface="Twentieth Century"/>
-                <a:ea typeface="Twentieth Century"/>
-                <a:cs typeface="Twentieth Century"/>
-                <a:sym typeface="Twentieth Century"/>
-              </a:rPr>
-              <a:t>MSE: 0.0431</a:t>
+              <a:t>MSE: 0.03093</a:t>
             </a:r>
           </a:p>
         </p:txBody>
@@ -17297,8 +16504,8 @@
         </p:nvSpPr>
         <p:spPr>
           <a:xfrm>
-            <a:off x="3772524" y="4656130"/>
-            <a:ext cx="1598952" cy="317166"/>
+            <a:off x="7085495" y="3640896"/>
+            <a:ext cx="1826275" cy="317165"/>
           </a:xfrm>
           <a:prstGeom prst="rect">
             <a:avLst/>
@@ -17341,7 +16548,7 @@
                 <a:cs typeface="Twentieth Century"/>
                 <a:sym typeface="Twentieth Century"/>
               </a:rPr>
-              <a:t>MSE: 0.0457</a:t>
+              <a:t>MSE: 0.06069</a:t>
             </a:r>
           </a:p>
         </p:txBody>
@@ -17360,8 +16567,8 @@
         </p:nvSpPr>
         <p:spPr>
           <a:xfrm>
-            <a:off x="6588054" y="4597946"/>
-            <a:ext cx="1598952" cy="317166"/>
+            <a:off x="7085496" y="2758447"/>
+            <a:ext cx="1955502" cy="317165"/>
           </a:xfrm>
           <a:prstGeom prst="rect">
             <a:avLst/>
@@ -17404,17 +16611,17 @@
                 <a:cs typeface="Twentieth Century"/>
                 <a:sym typeface="Twentieth Century"/>
               </a:rPr>
-              <a:t>MSE: 0.0440</a:t>
+              <a:t>MSE: 0.02926</a:t>
             </a:r>
           </a:p>
         </p:txBody>
       </p:sp>
       <p:pic>
         <p:nvPicPr>
-          <p:cNvPr id="5" name="Imagen 4">
+          <p:cNvPr id="3" name="Picture 2">
             <a:extLst>
               <a:ext uri="{FF2B5EF4-FFF2-40B4-BE49-F238E27FC236}">
-                <a16:creationId xmlns:a16="http://schemas.microsoft.com/office/drawing/2014/main" id="{6D46FC77-5229-22CA-AB3E-65B9588CE8DB}"/>
+                <a16:creationId xmlns:a16="http://schemas.microsoft.com/office/drawing/2014/main" id="{8E821BB5-4B0C-F9FC-6B0E-F2C5762ADCC2}"/>
               </a:ext>
             </a:extLst>
           </p:cNvPr>
@@ -17431,74 +16638,77 @@
         </p:blipFill>
         <p:spPr>
           <a:xfrm>
-            <a:off x="53797" y="2269368"/>
-            <a:ext cx="2880000" cy="1440000"/>
+            <a:off x="103001" y="760084"/>
+            <a:ext cx="6575918" cy="4313891"/>
           </a:xfrm>
           <a:prstGeom prst="rect">
             <a:avLst/>
           </a:prstGeom>
         </p:spPr>
       </p:pic>
-      <p:pic>
-        <p:nvPicPr>
-          <p:cNvPr id="14" name="Imagen 13">
+      <p:sp>
+        <p:nvSpPr>
+          <p:cNvPr id="8" name="Google Shape;189;g2f19d644e1e_1_90">
             <a:extLst>
               <a:ext uri="{FF2B5EF4-FFF2-40B4-BE49-F238E27FC236}">
-                <a16:creationId xmlns:a16="http://schemas.microsoft.com/office/drawing/2014/main" id="{E15E41EE-6008-E7F4-8976-B6C2188F6885}"/>
+                <a16:creationId xmlns:a16="http://schemas.microsoft.com/office/drawing/2014/main" id="{871E2BA6-D16B-11DE-0106-60D3A846CFF5}"/>
               </a:ext>
             </a:extLst>
           </p:cNvPr>
-          <p:cNvPicPr>
-            <a:picLocks noChangeAspect="1"/>
-          </p:cNvPicPr>
+          <p:cNvSpPr txBox="1"/>
           <p:nvPr/>
-        </p:nvPicPr>
-        <p:blipFill>
-          <a:blip r:embed="rId4"/>
-          <a:stretch>
-            <a:fillRect/>
-          </a:stretch>
-        </p:blipFill>
+        </p:nvSpPr>
         <p:spPr>
           <a:xfrm>
-            <a:off x="3122298" y="2269368"/>
-            <a:ext cx="2880000" cy="1440000"/>
+            <a:off x="7085496" y="4523346"/>
+            <a:ext cx="1826274" cy="317165"/>
           </a:xfrm>
           <a:prstGeom prst="rect">
             <a:avLst/>
           </a:prstGeom>
+          <a:noFill/>
+          <a:ln>
+            <a:noFill/>
+          </a:ln>
         </p:spPr>
-      </p:pic>
-      <p:pic>
-        <p:nvPicPr>
-          <p:cNvPr id="16" name="Imagen 15">
-            <a:extLst>
-              <a:ext uri="{FF2B5EF4-FFF2-40B4-BE49-F238E27FC236}">
-                <a16:creationId xmlns:a16="http://schemas.microsoft.com/office/drawing/2014/main" id="{00191610-9F0D-9904-AF50-B51EF8BB15EC}"/>
-              </a:ext>
-            </a:extLst>
-          </p:cNvPr>
-          <p:cNvPicPr>
-            <a:picLocks noChangeAspect="1"/>
-          </p:cNvPicPr>
-          <p:nvPr/>
-        </p:nvPicPr>
-        <p:blipFill>
-          <a:blip r:embed="rId5"/>
-          <a:stretch>
-            <a:fillRect/>
-          </a:stretch>
-        </p:blipFill>
-        <p:spPr>
-          <a:xfrm>
-            <a:off x="6118917" y="2269368"/>
-            <a:ext cx="2880000" cy="1440000"/>
-          </a:xfrm>
-          <a:prstGeom prst="rect">
-            <a:avLst/>
-          </a:prstGeom>
-        </p:spPr>
-      </p:pic>
+        <p:txBody>
+          <a:bodyPr spcFirstLastPara="1" wrap="square" lIns="68575" tIns="34275" rIns="68575" bIns="34275" anchor="t" anchorCtr="0">
+            <a:noAutofit/>
+          </a:bodyPr>
+          <a:lstStyle/>
+          <a:p>
+            <a:pPr marL="0" marR="0" lvl="0" indent="0" algn="l" rtl="0">
+              <a:lnSpc>
+                <a:spcPct val="90000"/>
+              </a:lnSpc>
+              <a:spcBef>
+                <a:spcPts val="0"/>
+              </a:spcBef>
+              <a:spcAft>
+                <a:spcPts val="0"/>
+              </a:spcAft>
+              <a:buClr>
+                <a:srgbClr val="FF0000"/>
+              </a:buClr>
+              <a:buSzPts val="2100"/>
+              <a:buFont typeface="Arial"/>
+              <a:buNone/>
+            </a:pPr>
+            <a:r>
+              <a:rPr lang="es-AR" sz="2100" dirty="0">
+                <a:solidFill>
+                  <a:srgbClr val="FF0000"/>
+                </a:solidFill>
+                <a:latin typeface="Twentieth Century"/>
+                <a:ea typeface="Twentieth Century"/>
+                <a:cs typeface="Twentieth Century"/>
+                <a:sym typeface="Twentieth Century"/>
+              </a:rPr>
+              <a:t>MSE: 0,10407</a:t>
+            </a:r>
+          </a:p>
+        </p:txBody>
+      </p:sp>
     </p:spTree>
     <p:extLst>
       <p:ext uri="{BB962C8B-B14F-4D97-AF65-F5344CB8AC3E}">
@@ -22144,8 +21354,8 @@
           </p:sp>
         </mc:Fallback>
       </mc:AlternateContent>
-      <mc:AlternateContent xmlns:mc="http://schemas.openxmlformats.org/markup-compatibility/2006">
-        <mc:Choice xmlns:a14="http://schemas.microsoft.com/office/drawing/2010/main" Requires="a14">
+      <mc:AlternateContent xmlns:mc="http://schemas.openxmlformats.org/markup-compatibility/2006" xmlns:a14="http://schemas.microsoft.com/office/drawing/2010/main">
+        <mc:Choice Requires="a14">
           <p:sp>
             <p:nvSpPr>
               <p:cNvPr id="7" name="CuadroTexto 6">
@@ -22262,7 +21472,7 @@
             </p:txBody>
           </p:sp>
         </mc:Choice>
-        <mc:Fallback>
+        <mc:Fallback xmlns="">
           <p:sp>
             <p:nvSpPr>
               <p:cNvPr id="7" name="CuadroTexto 6">
@@ -24082,7 +23292,7 @@
                 <a:latin typeface="Twentieth Century"/>
                 <a:sym typeface="Twentieth Century"/>
               </a:rPr>
-              <a:t>¿Cuantos es 240 divido 6?			Y… ¿Cuánto es CCXL divido VI?</a:t>
+              <a:t>¿Cuánto es CCXL divido VI?</a:t>
             </a:r>
             <a:endParaRPr sz="1100" dirty="0">
               <a:solidFill>
@@ -24284,6 +23494,64 @@
           </a:p>
         </p:txBody>
       </p:sp>
+      <p:sp>
+        <p:nvSpPr>
+          <p:cNvPr id="3" name="Google Shape;202;g2f19d644e1e_1_101">
+            <a:extLst>
+              <a:ext uri="{FF2B5EF4-FFF2-40B4-BE49-F238E27FC236}">
+                <a16:creationId xmlns:a16="http://schemas.microsoft.com/office/drawing/2014/main" id="{BAD49A31-48C8-3780-594C-E0125770125F}"/>
+              </a:ext>
+            </a:extLst>
+          </p:cNvPr>
+          <p:cNvSpPr/>
+          <p:nvPr/>
+        </p:nvSpPr>
+        <p:spPr>
+          <a:xfrm>
+            <a:off x="5074724" y="1264979"/>
+            <a:ext cx="2981863" cy="474861"/>
+          </a:xfrm>
+          <a:prstGeom prst="rect">
+            <a:avLst/>
+          </a:prstGeom>
+          <a:noFill/>
+          <a:ln>
+            <a:noFill/>
+          </a:ln>
+        </p:spPr>
+        <p:txBody>
+          <a:bodyPr spcFirstLastPara="1" wrap="square" lIns="68575" tIns="34275" rIns="68575" bIns="34275" anchor="t" anchorCtr="0">
+            <a:noAutofit/>
+          </a:bodyPr>
+          <a:lstStyle/>
+          <a:p>
+            <a:pPr marL="0" marR="0" lvl="0" indent="0" algn="l" rtl="0">
+              <a:spcBef>
+                <a:spcPts val="0"/>
+              </a:spcBef>
+              <a:spcAft>
+                <a:spcPts val="0"/>
+              </a:spcAft>
+              <a:buNone/>
+            </a:pPr>
+            <a:r>
+              <a:rPr lang="es-ES" sz="1800" dirty="0">
+                <a:solidFill>
+                  <a:schemeClr val="dk2"/>
+                </a:solidFill>
+                <a:latin typeface="Twentieth Century"/>
+                <a:sym typeface="Twentieth Century"/>
+              </a:rPr>
+              <a:t>y…. ¿Cuanto es 240 divido 6?</a:t>
+            </a:r>
+            <a:endParaRPr sz="1100" dirty="0">
+              <a:solidFill>
+                <a:schemeClr val="dk2"/>
+              </a:solidFill>
+            </a:endParaRPr>
+          </a:p>
+        </p:txBody>
+      </p:sp>
     </p:spTree>
     <p:extLst>
       <p:ext uri="{BB962C8B-B14F-4D97-AF65-F5344CB8AC3E}">
@@ -24294,6 +23562,249 @@
   <p:clrMapOvr>
     <a:masterClrMapping/>
   </p:clrMapOvr>
+  <p:timing>
+    <p:tnLst>
+      <p:par>
+        <p:cTn id="1" dur="indefinite" restart="never" nodeType="tmRoot">
+          <p:childTnLst>
+            <p:seq concurrent="1" nextAc="seek">
+              <p:cTn id="2" dur="indefinite" nodeType="mainSeq">
+                <p:childTnLst>
+                  <p:par>
+                    <p:cTn id="3" fill="hold">
+                      <p:stCondLst>
+                        <p:cond delay="indefinite"/>
+                        <p:cond evt="onBegin" delay="0">
+                          <p:tn val="2"/>
+                        </p:cond>
+                      </p:stCondLst>
+                      <p:childTnLst>
+                        <p:par>
+                          <p:cTn id="4" fill="hold">
+                            <p:stCondLst>
+                              <p:cond delay="0"/>
+                            </p:stCondLst>
+                            <p:childTnLst>
+                              <p:par>
+                                <p:cTn id="5" presetID="10" presetClass="entr" presetSubtype="0" fill="hold" grpId="0" nodeType="afterEffect">
+                                  <p:stCondLst>
+                                    <p:cond delay="0"/>
+                                  </p:stCondLst>
+                                  <p:childTnLst>
+                                    <p:set>
+                                      <p:cBhvr>
+                                        <p:cTn id="6" dur="1" fill="hold">
+                                          <p:stCondLst>
+                                            <p:cond delay="0"/>
+                                          </p:stCondLst>
+                                        </p:cTn>
+                                        <p:tgtEl>
+                                          <p:spTgt spid="202"/>
+                                        </p:tgtEl>
+                                        <p:attrNameLst>
+                                          <p:attrName>style.visibility</p:attrName>
+                                        </p:attrNameLst>
+                                      </p:cBhvr>
+                                      <p:to>
+                                        <p:strVal val="visible"/>
+                                      </p:to>
+                                    </p:set>
+                                    <p:animEffect transition="in" filter="fade">
+                                      <p:cBhvr>
+                                        <p:cTn id="7" dur="500"/>
+                                        <p:tgtEl>
+                                          <p:spTgt spid="202"/>
+                                        </p:tgtEl>
+                                      </p:cBhvr>
+                                    </p:animEffect>
+                                  </p:childTnLst>
+                                </p:cTn>
+                              </p:par>
+                            </p:childTnLst>
+                          </p:cTn>
+                        </p:par>
+                      </p:childTnLst>
+                    </p:cTn>
+                  </p:par>
+                  <p:par>
+                    <p:cTn id="8" fill="hold">
+                      <p:stCondLst>
+                        <p:cond delay="indefinite"/>
+                      </p:stCondLst>
+                      <p:childTnLst>
+                        <p:par>
+                          <p:cTn id="9" fill="hold">
+                            <p:stCondLst>
+                              <p:cond delay="0"/>
+                            </p:stCondLst>
+                            <p:childTnLst>
+                              <p:par>
+                                <p:cTn id="10" presetID="10" presetClass="entr" presetSubtype="0" fill="hold" grpId="0" nodeType="clickEffect">
+                                  <p:stCondLst>
+                                    <p:cond delay="0"/>
+                                  </p:stCondLst>
+                                  <p:childTnLst>
+                                    <p:set>
+                                      <p:cBhvr>
+                                        <p:cTn id="11" dur="1" fill="hold">
+                                          <p:stCondLst>
+                                            <p:cond delay="0"/>
+                                          </p:stCondLst>
+                                        </p:cTn>
+                                        <p:tgtEl>
+                                          <p:spTgt spid="3"/>
+                                        </p:tgtEl>
+                                        <p:attrNameLst>
+                                          <p:attrName>style.visibility</p:attrName>
+                                        </p:attrNameLst>
+                                      </p:cBhvr>
+                                      <p:to>
+                                        <p:strVal val="visible"/>
+                                      </p:to>
+                                    </p:set>
+                                    <p:animEffect transition="in" filter="fade">
+                                      <p:cBhvr>
+                                        <p:cTn id="12" dur="500"/>
+                                        <p:tgtEl>
+                                          <p:spTgt spid="3"/>
+                                        </p:tgtEl>
+                                      </p:cBhvr>
+                                    </p:animEffect>
+                                  </p:childTnLst>
+                                </p:cTn>
+                              </p:par>
+                            </p:childTnLst>
+                          </p:cTn>
+                        </p:par>
+                      </p:childTnLst>
+                    </p:cTn>
+                  </p:par>
+                  <p:par>
+                    <p:cTn id="13" fill="hold">
+                      <p:stCondLst>
+                        <p:cond delay="indefinite"/>
+                      </p:stCondLst>
+                      <p:childTnLst>
+                        <p:par>
+                          <p:cTn id="14" fill="hold">
+                            <p:stCondLst>
+                              <p:cond delay="0"/>
+                            </p:stCondLst>
+                            <p:childTnLst>
+                              <p:par>
+                                <p:cTn id="15" presetID="42" presetClass="entr" presetSubtype="0" fill="hold" grpId="0" nodeType="clickEffect">
+                                  <p:stCondLst>
+                                    <p:cond delay="0"/>
+                                  </p:stCondLst>
+                                  <p:childTnLst>
+                                    <p:set>
+                                      <p:cBhvr>
+                                        <p:cTn id="16" dur="1" fill="hold">
+                                          <p:stCondLst>
+                                            <p:cond delay="0"/>
+                                          </p:stCondLst>
+                                        </p:cTn>
+                                        <p:tgtEl>
+                                          <p:spTgt spid="206"/>
+                                        </p:tgtEl>
+                                        <p:attrNameLst>
+                                          <p:attrName>style.visibility</p:attrName>
+                                        </p:attrNameLst>
+                                      </p:cBhvr>
+                                      <p:to>
+                                        <p:strVal val="visible"/>
+                                      </p:to>
+                                    </p:set>
+                                    <p:animEffect transition="in" filter="fade">
+                                      <p:cBhvr>
+                                        <p:cTn id="17" dur="1000"/>
+                                        <p:tgtEl>
+                                          <p:spTgt spid="206"/>
+                                        </p:tgtEl>
+                                      </p:cBhvr>
+                                    </p:animEffect>
+                                    <p:anim calcmode="lin" valueType="num">
+                                      <p:cBhvr>
+                                        <p:cTn id="18" dur="1000" fill="hold"/>
+                                        <p:tgtEl>
+                                          <p:spTgt spid="206"/>
+                                        </p:tgtEl>
+                                        <p:attrNameLst>
+                                          <p:attrName>ppt_x</p:attrName>
+                                        </p:attrNameLst>
+                                      </p:cBhvr>
+                                      <p:tavLst>
+                                        <p:tav tm="0">
+                                          <p:val>
+                                            <p:strVal val="#ppt_x"/>
+                                          </p:val>
+                                        </p:tav>
+                                        <p:tav tm="100000">
+                                          <p:val>
+                                            <p:strVal val="#ppt_x"/>
+                                          </p:val>
+                                        </p:tav>
+                                      </p:tavLst>
+                                    </p:anim>
+                                    <p:anim calcmode="lin" valueType="num">
+                                      <p:cBhvr>
+                                        <p:cTn id="19" dur="1000" fill="hold"/>
+                                        <p:tgtEl>
+                                          <p:spTgt spid="206"/>
+                                        </p:tgtEl>
+                                        <p:attrNameLst>
+                                          <p:attrName>ppt_y</p:attrName>
+                                        </p:attrNameLst>
+                                      </p:cBhvr>
+                                      <p:tavLst>
+                                        <p:tav tm="0">
+                                          <p:val>
+                                            <p:strVal val="#ppt_y+.1"/>
+                                          </p:val>
+                                        </p:tav>
+                                        <p:tav tm="100000">
+                                          <p:val>
+                                            <p:strVal val="#ppt_y"/>
+                                          </p:val>
+                                        </p:tav>
+                                      </p:tavLst>
+                                    </p:anim>
+                                  </p:childTnLst>
+                                </p:cTn>
+                              </p:par>
+                            </p:childTnLst>
+                          </p:cTn>
+                        </p:par>
+                      </p:childTnLst>
+                    </p:cTn>
+                  </p:par>
+                </p:childTnLst>
+              </p:cTn>
+              <p:prevCondLst>
+                <p:cond evt="onPrev" delay="0">
+                  <p:tgtEl>
+                    <p:sldTgt/>
+                  </p:tgtEl>
+                </p:cond>
+              </p:prevCondLst>
+              <p:nextCondLst>
+                <p:cond evt="onNext" delay="0">
+                  <p:tgtEl>
+                    <p:sldTgt/>
+                  </p:tgtEl>
+                </p:cond>
+              </p:nextCondLst>
+            </p:seq>
+          </p:childTnLst>
+        </p:cTn>
+      </p:par>
+    </p:tnLst>
+    <p:bldLst>
+      <p:bldP spid="202" grpId="0"/>
+      <p:bldP spid="206" grpId="0"/>
+      <p:bldP spid="3" grpId="0"/>
+    </p:bldLst>
+  </p:timing>
 </p:sld>
 </file>
 

</xml_diff>